<commit_message>
docs: PPT actualizado (primera persona + casillero, modo voz, PWA)
Co-Authored-By: Claude Opus 4.8 <noreply@anthropic.com>
</commit_message>
<xml_diff>
--- a/Ventanilla-Inclusiva.pptx
+++ b/Ventanilla-Inclusiva.pptx
@@ -2118,7 +2118,7 @@
                 <a:ea typeface="Calibri" pitchFamily="34" charset="-122"/>
                 <a:cs typeface="Calibri" pitchFamily="34" charset="-120"/>
               </a:rPr>
-              <a:t>Un asistente conversacional guiado y accesible (WCAG 2.2) que permite a una persona ciega presentar y consultar una solicitud de acceso a información pública de forma autónoma y privada, usando su propio lector de pantalla.</a:t>
+              <a:t>Construí un sistema de mesa de partes inclusiva: ingresar a un casillero, presentar una solicitud (con adjuntos), recibir el expediente y darle seguimiento — todo accesible (WCAG 2.2), con su propio lector de pantalla, de forma autónoma y privada.</a:t>
             </a:r>
             <a:endParaRPr lang="en-US" sz="2200" dirty="0"/>
           </a:p>
@@ -3068,7 +3068,7 @@
                 <a:ea typeface="Calibri" pitchFamily="34" charset="-122"/>
                 <a:cs typeface="Calibri" pitchFamily="34" charset="-120"/>
               </a:rPr>
-              <a:t>🎙️  Comandos de voz en español (manos libres)
+              <a:t>🗂️  Casillero electrónico: ve tus solicitudes
 </a:t>
             </a:r>
             <a:pPr indent="0" marL="0">
@@ -3086,7 +3086,7 @@
                 <a:ea typeface="Calibri" pitchFamily="34" charset="-122"/>
                 <a:cs typeface="Calibri" pitchFamily="34" charset="-120"/>
               </a:rPr>
-              <a:t>🗣️  Audio de apoyo en quechua por paso
+              <a:t>🔊  Modo voz: la app lee sola, sin instalar nada
 </a:t>
             </a:r>
             <a:pPr indent="0" marL="0">
@@ -3104,7 +3104,7 @@
                 <a:ea typeface="Calibri" pitchFamily="34" charset="-122"/>
                 <a:cs typeface="Calibri" pitchFamily="34" charset="-120"/>
               </a:rPr>
-              <a:t>⚠️  Identificación de errores accesible
+              <a:t>🎙️  Comandos de voz en español (manos libres)
 </a:t>
             </a:r>
             <a:pPr indent="0" marL="0">
@@ -3122,7 +3122,7 @@
                 <a:ea typeface="Calibri" pitchFamily="34" charset="-122"/>
                 <a:cs typeface="Calibri" pitchFamily="34" charset="-120"/>
               </a:rPr>
-              <a:t>🔎  Consulta de estado por nº de expediente</a:t>
+              <a:t>📱  App instalable (PWA) que funciona offline</a:t>
             </a:r>
             <a:endParaRPr lang="en-US" sz="1500" dirty="0"/>
           </a:p>

</xml_diff>

<commit_message>
docs: actualizar presentacion premium sin referencias a APK e incluir capturas
</commit_message>
<xml_diff>
--- a/Ventanilla-Inclusiva.pptx
+++ b/Ventanilla-Inclusiva.pptx
@@ -14,9 +14,10 @@
     <p:sldId id="262" r:id="rId8"/>
     <p:sldId id="263" r:id="rId9"/>
     <p:sldId id="264" r:id="rId10"/>
+    <p:sldId id="265" r:id="rId11"/>
   </p:sldIdLst>
   <p:notesMasterIdLst>
-    <p:notesMasterId r:id="rId11"/>
+    <p:notesMasterId r:id="rId12"/>
   </p:notesMasterIdLst>
   <p:sldSz cx="12192000" cy="6858000"/>
   <p:notesSz cx="6858000" cy="12192000"/>
@@ -534,6 +535,94 @@
             <a:fld id="{F7021451-1387-4CA6-816F-3879F97B5CBC}" type="slidenum">
               <a:rPr lang="en-US"/>
               <a:t>1</a:t>
+            </a:fld>
+            <a:endParaRPr lang="en-US"/>
+          </a:p>
+        </p:txBody>
+      </p:sp>
+    </p:spTree>
+    <p:extLst>
+      <p:ext uri="{BB962C8B-B14F-4D97-AF65-F5344CB8AC3E}">
+        <p14:creationId xmlns:p14="http://schemas.microsoft.com/office/powerpoint/2010/main" val="1024086991"/>
+      </p:ext>
+    </p:extLst>
+  </p:cSld>
+  <p:clrMapOvr>
+    <a:masterClrMapping/>
+  </p:clrMapOvr>
+</p:notes>
+</file>
+
+<file path=ppt/notesSlides/notesSlide10.xml><?xml version="1.0" encoding="utf-8"?>
+<p:notes xmlns:a="http://schemas.openxmlformats.org/drawingml/2006/main" xmlns:r="http://schemas.openxmlformats.org/officeDocument/2006/relationships" xmlns:p="http://schemas.openxmlformats.org/presentationml/2006/main">
+  <p:cSld>
+    <p:spTree>
+      <p:nvGrpSpPr>
+        <p:cNvPr id="1" name=""/>
+        <p:cNvGrpSpPr/>
+        <p:nvPr/>
+      </p:nvGrpSpPr>
+      <p:grpSpPr>
+        <a:xfrm>
+          <a:off x="0" y="0"/>
+          <a:ext cx="0" cy="0"/>
+          <a:chOff x="0" y="0"/>
+          <a:chExt cx="0" cy="0"/>
+        </a:xfrm>
+      </p:grpSpPr>
+      <p:sp>
+        <p:nvSpPr>
+          <p:cNvPr id="2" name="Slide Image Placeholder 1"/>
+          <p:cNvSpPr>
+            <a:spLocks noGrp="1" noRot="1" noChangeAspect="1"/>
+          </p:cNvSpPr>
+          <p:nvPr>
+            <p:ph type="sldImg"/>
+          </p:nvPr>
+        </p:nvSpPr>
+        <p:spPr/>
+      </p:sp>
+      <p:sp>
+        <p:nvSpPr>
+          <p:cNvPr id="3" name="Notes Placeholder 2"/>
+          <p:cNvSpPr>
+            <a:spLocks noGrp="1"/>
+          </p:cNvSpPr>
+          <p:nvPr>
+            <p:ph type="body" idx="1"/>
+          </p:nvPr>
+        </p:nvSpPr>
+        <p:spPr/>
+        <p:txBody>
+          <a:bodyPr/>
+          <a:lstStyle/>
+          <a:p>
+            <a:r>
+              <a:rPr lang="en-US" dirty="0"/>
+              <a:t/>
+            </a:r>
+            <a:endParaRPr lang="en-US" dirty="0"/>
+          </a:p>
+        </p:txBody>
+      </p:sp>
+      <p:sp>
+        <p:nvSpPr>
+          <p:cNvPr id="4" name="Slide Number Placeholder 3"/>
+          <p:cNvSpPr>
+            <a:spLocks noGrp="1"/>
+          </p:cNvSpPr>
+          <p:nvPr>
+            <p:ph type="sldNum" sz="quarter" idx="10"/>
+          </p:nvPr>
+        </p:nvSpPr>
+        <p:spPr/>
+        <p:txBody>
+          <a:bodyPr/>
+          <a:lstStyle/>
+          <a:p>
+            <a:fld id="{F7021451-1387-4CA6-816F-3879F97B5CBC}" type="slidenum">
+              <a:rPr lang="en-US"/>
+              <a:t>10</a:t>
             </a:fld>
             <a:endParaRPr lang="en-US"/>
           </a:p>
@@ -1712,6 +1801,116 @@
 </p:sld>
 </file>
 
+<file path=ppt/slides/slide10.xml><?xml version="1.0" encoding="utf-8"?>
+<p:sld xmlns:a="http://schemas.openxmlformats.org/drawingml/2006/main" xmlns:r="http://schemas.openxmlformats.org/officeDocument/2006/relationships" xmlns:p="http://schemas.openxmlformats.org/presentationml/2006/main">
+  <p:cSld name="Slide 10">
+    <p:bg>
+      <p:bgPr>
+        <a:solidFill>
+          <a:srgbClr val="0B3D91"/>
+        </a:solidFill>
+      </p:bgPr>
+    </p:bg>
+    <p:spTree>
+      <p:nvGrpSpPr>
+        <p:cNvPr id="1" name=""/>
+        <p:cNvGrpSpPr/>
+        <p:nvPr/>
+      </p:nvGrpSpPr>
+      <p:grpSpPr>
+        <a:xfrm>
+          <a:off x="0" y="0"/>
+          <a:ext cx="0" cy="0"/>
+          <a:chOff x="0" y="0"/>
+          <a:chExt cx="0" cy="0"/>
+        </a:xfrm>
+      </p:grpSpPr>
+      <p:sp>
+        <p:nvSpPr>
+          <p:cNvPr id="2" name="Text 0"/>
+          <p:cNvSpPr/>
+          <p:nvPr/>
+        </p:nvSpPr>
+        <p:spPr>
+          <a:xfrm>
+            <a:off x="914400" y="2103120"/>
+            <a:ext cx="10332720" cy="1645920"/>
+          </a:xfrm>
+          <a:prstGeom prst="rect">
+            <a:avLst/>
+          </a:prstGeom>
+          <a:noFill/>
+          <a:ln/>
+        </p:spPr>
+        <p:txBody>
+          <a:bodyPr wrap="square" rtlCol="0" anchor="ctr"/>
+          <a:lstStyle/>
+          <a:p>
+            <a:pPr indent="0" marL="0">
+              <a:buNone/>
+            </a:pPr>
+            <a:r>
+              <a:rPr lang="en-US" sz="3200" b="1" i="1" dirty="0">
+                <a:solidFill>
+                  <a:srgbClr val="FFFFFF"/>
+                </a:solidFill>
+                <a:latin typeface="Georgia" pitchFamily="34" charset="0"/>
+                <a:ea typeface="Georgia" pitchFamily="34" charset="-122"/>
+                <a:cs typeface="Georgia" pitchFamily="34" charset="-120"/>
+              </a:rPr>
+              <a:t>"Una ventanilla que funciona con las herramientas que la ciudadanía ya usa."</a:t>
+            </a:r>
+            <a:endParaRPr lang="en-US" sz="3200" dirty="0"/>
+          </a:p>
+        </p:txBody>
+      </p:sp>
+      <p:sp>
+        <p:nvSpPr>
+          <p:cNvPr id="3" name="Text 1"/>
+          <p:cNvSpPr/>
+          <p:nvPr/>
+        </p:nvSpPr>
+        <p:spPr>
+          <a:xfrm>
+            <a:off x="914400" y="5212080"/>
+            <a:ext cx="5486400" cy="640080"/>
+          </a:xfrm>
+          <a:prstGeom prst="rect">
+            <a:avLst/>
+          </a:prstGeom>
+          <a:noFill/>
+          <a:ln/>
+        </p:spPr>
+        <p:txBody>
+          <a:bodyPr wrap="square" rtlCol="0" anchor="ctr"/>
+          <a:lstStyle/>
+          <a:p>
+            <a:pPr indent="0" marL="0">
+              <a:buNone/>
+            </a:pPr>
+            <a:r>
+              <a:rPr lang="en-US" sz="2400" dirty="0">
+                <a:solidFill>
+                  <a:srgbClr val="E0A100"/>
+                </a:solidFill>
+                <a:latin typeface="Georgia" pitchFamily="34" charset="0"/>
+                <a:ea typeface="Georgia" pitchFamily="34" charset="-122"/>
+                <a:cs typeface="Georgia" pitchFamily="34" charset="-120"/>
+              </a:rPr>
+              <a:t>Gracias.</a:t>
+            </a:r>
+            <a:endParaRPr lang="en-US" sz="2400" dirty="0"/>
+          </a:p>
+        </p:txBody>
+      </p:sp>
+    </p:spTree>
+  </p:cSld>
+  <p:clrMapOvr>
+    <a:masterClrMapping/>
+  </p:clrMapOvr>
+</p:sld>
+</file>
+
 <file path=ppt/slides/slide2.xml><?xml version="1.0" encoding="utf-8"?>
 <p:sld xmlns:a="http://schemas.openxmlformats.org/drawingml/2006/main" xmlns:r="http://schemas.openxmlformats.org/officeDocument/2006/relationships" xmlns:p="http://schemas.openxmlformats.org/presentationml/2006/main">
   <p:cSld name="Slide 2">
@@ -1744,8 +1943,8 @@
         </p:nvSpPr>
         <p:spPr>
           <a:xfrm>
-            <a:off x="640080" y="457200"/>
-            <a:ext cx="10908792" cy="822960"/>
+            <a:off x="640080" y="365760"/>
+            <a:ext cx="10908792" cy="731520"/>
           </a:xfrm>
           <a:prstGeom prst="rect">
             <a:avLst/>
@@ -1761,7 +1960,7 @@
               <a:buNone/>
             </a:pPr>
             <a:r>
-              <a:rPr lang="en-US" sz="3400" b="1" dirty="0">
+              <a:rPr lang="en-US" sz="3200" b="1" dirty="0">
                 <a:solidFill>
                   <a:srgbClr val="0B3D91"/>
                 </a:solidFill>
@@ -1771,13 +1970,33 @@
               </a:rPr>
               <a:t>El problema</a:t>
             </a:r>
-            <a:endParaRPr lang="en-US" sz="3400" dirty="0"/>
-          </a:p>
-        </p:txBody>
-      </p:sp>
-      <p:sp>
-        <p:nvSpPr>
-          <p:cNvPr id="3" name="Text 1"/>
+            <a:endParaRPr lang="en-US" sz="3200" dirty="0"/>
+          </a:p>
+        </p:txBody>
+      </p:sp>
+      <p:sp>
+        <p:nvSpPr>
+          <p:cNvPr id="3" name="Shape 1"/>
+          <p:cNvSpPr/>
+          <p:nvPr/>
+        </p:nvSpPr>
+        <p:spPr>
+          <a:xfrm>
+            <a:off x="640080" y="1051560"/>
+            <a:ext cx="1097280" cy="45720"/>
+          </a:xfrm>
+          <a:prstGeom prst="rect">
+            <a:avLst/>
+          </a:prstGeom>
+          <a:solidFill>
+            <a:srgbClr val="E0A100"/>
+          </a:solidFill>
+          <a:ln/>
+        </p:spPr>
+      </p:sp>
+      <p:sp>
+        <p:nvSpPr>
+          <p:cNvPr id="4" name="Text 2"/>
           <p:cNvSpPr/>
           <p:nvPr/>
         </p:nvSpPr>
@@ -1816,7 +2035,7 @@
       </p:sp>
       <p:sp>
         <p:nvSpPr>
-          <p:cNvPr id="4" name="Text 2"/>
+          <p:cNvPr id="5" name="Text 3"/>
           <p:cNvSpPr/>
           <p:nvPr/>
         </p:nvSpPr>
@@ -1855,7 +2074,7 @@
       </p:sp>
       <p:sp>
         <p:nvSpPr>
-          <p:cNvPr id="5" name="Text 3"/>
+          <p:cNvPr id="6" name="Text 4"/>
           <p:cNvSpPr/>
           <p:nvPr/>
         </p:nvSpPr>
@@ -1915,7 +2134,7 @@
       </p:sp>
       <p:sp>
         <p:nvSpPr>
-          <p:cNvPr id="6" name="Shape 4"/>
+          <p:cNvPr id="7" name="Shape 5"/>
           <p:cNvSpPr/>
           <p:nvPr/>
         </p:nvSpPr>
@@ -1935,7 +2154,7 @@
       </p:sp>
       <p:sp>
         <p:nvSpPr>
-          <p:cNvPr id="7" name="Text 5"/>
+          <p:cNvPr id="8" name="Text 6"/>
           <p:cNvSpPr/>
           <p:nvPr/>
         </p:nvSpPr>
@@ -1974,7 +2193,7 @@
       </p:sp>
       <p:sp>
         <p:nvSpPr>
-          <p:cNvPr id="8" name="Text 6"/>
+          <p:cNvPr id="9" name="Text 7"/>
           <p:cNvSpPr/>
           <p:nvPr/>
         </p:nvSpPr>
@@ -2051,8 +2270,8 @@
         </p:nvSpPr>
         <p:spPr>
           <a:xfrm>
-            <a:off x="640080" y="457200"/>
-            <a:ext cx="10908792" cy="822960"/>
+            <a:off x="640080" y="365760"/>
+            <a:ext cx="10908792" cy="731520"/>
           </a:xfrm>
           <a:prstGeom prst="rect">
             <a:avLst/>
@@ -2068,7 +2287,7 @@
               <a:buNone/>
             </a:pPr>
             <a:r>
-              <a:rPr lang="en-US" sz="3400" b="1" dirty="0">
+              <a:rPr lang="en-US" sz="3200" b="1" dirty="0">
                 <a:solidFill>
                   <a:srgbClr val="0B3D91"/>
                 </a:solidFill>
@@ -2078,13 +2297,33 @@
               </a:rPr>
               <a:t>La solución</a:t>
             </a:r>
-            <a:endParaRPr lang="en-US" sz="3400" dirty="0"/>
-          </a:p>
-        </p:txBody>
-      </p:sp>
-      <p:sp>
-        <p:nvSpPr>
-          <p:cNvPr id="3" name="Text 1"/>
+            <a:endParaRPr lang="en-US" sz="3200" dirty="0"/>
+          </a:p>
+        </p:txBody>
+      </p:sp>
+      <p:sp>
+        <p:nvSpPr>
+          <p:cNvPr id="3" name="Shape 1"/>
+          <p:cNvSpPr/>
+          <p:nvPr/>
+        </p:nvSpPr>
+        <p:spPr>
+          <a:xfrm>
+            <a:off x="640080" y="1051560"/>
+            <a:ext cx="1097280" cy="45720"/>
+          </a:xfrm>
+          <a:prstGeom prst="rect">
+            <a:avLst/>
+          </a:prstGeom>
+          <a:solidFill>
+            <a:srgbClr val="E0A100"/>
+          </a:solidFill>
+          <a:ln/>
+        </p:spPr>
+      </p:sp>
+      <p:sp>
+        <p:nvSpPr>
+          <p:cNvPr id="4" name="Text 2"/>
           <p:cNvSpPr/>
           <p:nvPr/>
         </p:nvSpPr>
@@ -2118,7 +2357,7 @@
                 <a:ea typeface="Calibri" pitchFamily="34" charset="-122"/>
                 <a:cs typeface="Calibri" pitchFamily="34" charset="-120"/>
               </a:rPr>
-              <a:t>Construí un sistema de mesa de partes inclusiva: ingresar a un casillero, presentar una solicitud (con adjuntos), recibir el expediente y darle seguimiento — todo accesible (WCAG 2.2), con su propio lector de pantalla, de forma autónoma y privada.</a:t>
+              <a:t>Un asistente conversacional guiado y accesible (WCAG 2.2) que permite a una persona ciega presentar y consultar una solicitud de acceso a información pública de forma autónoma y privada, usando su propio lector de pantalla.</a:t>
             </a:r>
             <a:endParaRPr lang="en-US" sz="2200" dirty="0"/>
           </a:p>
@@ -2126,7 +2365,7 @@
       </p:sp>
       <p:sp>
         <p:nvSpPr>
-          <p:cNvPr id="4" name="Shape 2"/>
+          <p:cNvPr id="5" name="Shape 3"/>
           <p:cNvSpPr/>
           <p:nvPr/>
         </p:nvSpPr>
@@ -2148,7 +2387,7 @@
       </p:sp>
       <p:sp>
         <p:nvSpPr>
-          <p:cNvPr id="5" name="Text 3"/>
+          <p:cNvPr id="6" name="Text 4"/>
           <p:cNvSpPr/>
           <p:nvPr/>
         </p:nvSpPr>
@@ -2187,7 +2426,7 @@
       </p:sp>
       <p:sp>
         <p:nvSpPr>
-          <p:cNvPr id="6" name="Shape 4"/>
+          <p:cNvPr id="7" name="Shape 5"/>
           <p:cNvSpPr/>
           <p:nvPr/>
         </p:nvSpPr>
@@ -2209,7 +2448,7 @@
       </p:sp>
       <p:sp>
         <p:nvSpPr>
-          <p:cNvPr id="7" name="Text 5"/>
+          <p:cNvPr id="8" name="Text 6"/>
           <p:cNvSpPr/>
           <p:nvPr/>
         </p:nvSpPr>
@@ -2248,7 +2487,7 @@
       </p:sp>
       <p:sp>
         <p:nvSpPr>
-          <p:cNvPr id="8" name="Shape 6"/>
+          <p:cNvPr id="9" name="Shape 7"/>
           <p:cNvSpPr/>
           <p:nvPr/>
         </p:nvSpPr>
@@ -2270,7 +2509,7 @@
       </p:sp>
       <p:sp>
         <p:nvSpPr>
-          <p:cNvPr id="9" name="Text 7"/>
+          <p:cNvPr id="10" name="Text 8"/>
           <p:cNvSpPr/>
           <p:nvPr/>
         </p:nvSpPr>
@@ -2309,7 +2548,7 @@
       </p:sp>
       <p:sp>
         <p:nvSpPr>
-          <p:cNvPr id="10" name="Shape 8"/>
+          <p:cNvPr id="11" name="Shape 9"/>
           <p:cNvSpPr/>
           <p:nvPr/>
         </p:nvSpPr>
@@ -2331,7 +2570,7 @@
       </p:sp>
       <p:sp>
         <p:nvSpPr>
-          <p:cNvPr id="11" name="Text 9"/>
+          <p:cNvPr id="12" name="Text 10"/>
           <p:cNvSpPr/>
           <p:nvPr/>
         </p:nvSpPr>
@@ -2408,8 +2647,8 @@
         </p:nvSpPr>
         <p:spPr>
           <a:xfrm>
-            <a:off x="640080" y="457200"/>
-            <a:ext cx="10908792" cy="822960"/>
+            <a:off x="640080" y="365760"/>
+            <a:ext cx="10908792" cy="731520"/>
           </a:xfrm>
           <a:prstGeom prst="rect">
             <a:avLst/>
@@ -2425,7 +2664,7 @@
               <a:buNone/>
             </a:pPr>
             <a:r>
-              <a:rPr lang="en-US" sz="3400" b="1" dirty="0">
+              <a:rPr lang="en-US" sz="3200" b="1" dirty="0">
                 <a:solidFill>
                   <a:srgbClr val="0B3D91"/>
                 </a:solidFill>
@@ -2435,7 +2674,7 @@
               </a:rPr>
               <a:t>Cómo funciona el prototipo</a:t>
             </a:r>
-            <a:endParaRPr lang="en-US" sz="3400" dirty="0"/>
+            <a:endParaRPr lang="en-US" sz="3200" dirty="0"/>
           </a:p>
         </p:txBody>
       </p:sp>
@@ -2447,7 +2686,27 @@
         </p:nvSpPr>
         <p:spPr>
           <a:xfrm>
-            <a:off x="640080" y="1554480"/>
+            <a:off x="640080" y="1051560"/>
+            <a:ext cx="1097280" cy="45720"/>
+          </a:xfrm>
+          <a:prstGeom prst="rect">
+            <a:avLst/>
+          </a:prstGeom>
+          <a:solidFill>
+            <a:srgbClr val="E0A100"/>
+          </a:solidFill>
+          <a:ln/>
+        </p:spPr>
+      </p:sp>
+      <p:sp>
+        <p:nvSpPr>
+          <p:cNvPr id="4" name="Shape 2"/>
+          <p:cNvSpPr/>
+          <p:nvPr/>
+        </p:nvSpPr>
+        <p:spPr>
+          <a:xfrm>
+            <a:off x="640080" y="1234440"/>
             <a:ext cx="640080" cy="640080"/>
           </a:xfrm>
           <a:prstGeom prst="ellipse">
@@ -2461,13 +2720,13 @@
       </p:sp>
       <p:sp>
         <p:nvSpPr>
-          <p:cNvPr id="4" name="Text 2"/>
-          <p:cNvSpPr/>
-          <p:nvPr/>
-        </p:nvSpPr>
-        <p:spPr>
-          <a:xfrm>
-            <a:off x="640080" y="1554480"/>
+          <p:cNvPr id="5" name="Text 3"/>
+          <p:cNvSpPr/>
+          <p:nvPr/>
+        </p:nvSpPr>
+        <p:spPr>
+          <a:xfrm>
+            <a:off x="640080" y="1234440"/>
             <a:ext cx="640080" cy="640080"/>
           </a:xfrm>
           <a:prstGeom prst="rect">
@@ -2500,14 +2759,14 @@
       </p:sp>
       <p:sp>
         <p:nvSpPr>
-          <p:cNvPr id="5" name="Text 3"/>
-          <p:cNvSpPr/>
-          <p:nvPr/>
-        </p:nvSpPr>
-        <p:spPr>
-          <a:xfrm>
-            <a:off x="1463040" y="1508760"/>
-            <a:ext cx="3657600" cy="457200"/>
+          <p:cNvPr id="6" name="Text 4"/>
+          <p:cNvSpPr/>
+          <p:nvPr/>
+        </p:nvSpPr>
+        <p:spPr>
+          <a:xfrm>
+            <a:off x="1463040" y="1188720"/>
+            <a:ext cx="4572000" cy="365760"/>
           </a:xfrm>
           <a:prstGeom prst="rect">
             <a:avLst/>
@@ -2523,7 +2782,7 @@
               <a:buNone/>
             </a:pPr>
             <a:r>
-              <a:rPr lang="en-US" sz="1900" b="1" dirty="0">
+              <a:rPr lang="en-US" sz="1800" b="1" dirty="0">
                 <a:solidFill>
                   <a:srgbClr val="0B3D91"/>
                 </a:solidFill>
@@ -2531,22 +2790,22 @@
                 <a:ea typeface="Georgia" pitchFamily="34" charset="-122"/>
                 <a:cs typeface="Georgia" pitchFamily="34" charset="-120"/>
               </a:rPr>
-              <a:t>Tus datos</a:t>
-            </a:r>
-            <a:endParaRPr lang="en-US" sz="1900" dirty="0"/>
-          </a:p>
-        </p:txBody>
-      </p:sp>
-      <p:sp>
-        <p:nvSpPr>
-          <p:cNvPr id="6" name="Text 4"/>
-          <p:cNvSpPr/>
-          <p:nvPr/>
-        </p:nvSpPr>
-        <p:spPr>
-          <a:xfrm>
-            <a:off x="1463040" y="1920240"/>
-            <a:ext cx="4754880" cy="457200"/>
+              <a:t>Trámite TUPA</a:t>
+            </a:r>
+            <a:endParaRPr lang="en-US" sz="1800" dirty="0"/>
+          </a:p>
+        </p:txBody>
+      </p:sp>
+      <p:sp>
+        <p:nvSpPr>
+          <p:cNvPr id="7" name="Text 5"/>
+          <p:cNvSpPr/>
+          <p:nvPr/>
+        </p:nvSpPr>
+        <p:spPr>
+          <a:xfrm>
+            <a:off x="1463040" y="1554480"/>
+            <a:ext cx="4754880" cy="365760"/>
           </a:xfrm>
           <a:prstGeom prst="rect">
             <a:avLst/>
@@ -2562,7 +2821,7 @@
               <a:buNone/>
             </a:pPr>
             <a:r>
-              <a:rPr lang="en-US" sz="1400" dirty="0">
+              <a:rPr lang="en-US" sz="1300" dirty="0">
                 <a:solidFill>
                   <a:srgbClr val="566077"/>
                 </a:solidFill>
@@ -2570,21 +2829,21 @@
                 <a:ea typeface="Calibri" pitchFamily="34" charset="-122"/>
                 <a:cs typeface="Calibri" pitchFamily="34" charset="-120"/>
               </a:rPr>
-              <a:t>Nombre, DNI y correo, paso a paso.</a:t>
-            </a:r>
-            <a:endParaRPr lang="en-US" sz="1400" dirty="0"/>
-          </a:p>
-        </p:txBody>
-      </p:sp>
-      <p:sp>
-        <p:nvSpPr>
-          <p:cNvPr id="7" name="Shape 5"/>
-          <p:cNvSpPr/>
-          <p:nvPr/>
-        </p:nvSpPr>
-        <p:spPr>
-          <a:xfrm>
-            <a:off x="640080" y="2606040"/>
+              <a:t>Selección accesible del trámite (Copias, Transparencia, etc.)</a:t>
+            </a:r>
+            <a:endParaRPr lang="en-US" sz="1300" dirty="0"/>
+          </a:p>
+        </p:txBody>
+      </p:sp>
+      <p:sp>
+        <p:nvSpPr>
+          <p:cNvPr id="8" name="Shape 6"/>
+          <p:cNvSpPr/>
+          <p:nvPr/>
+        </p:nvSpPr>
+        <p:spPr>
+          <a:xfrm>
+            <a:off x="640080" y="2240280"/>
             <a:ext cx="640080" cy="640080"/>
           </a:xfrm>
           <a:prstGeom prst="ellipse">
@@ -2598,13 +2857,13 @@
       </p:sp>
       <p:sp>
         <p:nvSpPr>
-          <p:cNvPr id="8" name="Text 6"/>
-          <p:cNvSpPr/>
-          <p:nvPr/>
-        </p:nvSpPr>
-        <p:spPr>
-          <a:xfrm>
-            <a:off x="640080" y="2606040"/>
+          <p:cNvPr id="9" name="Text 7"/>
+          <p:cNvSpPr/>
+          <p:nvPr/>
+        </p:nvSpPr>
+        <p:spPr>
+          <a:xfrm>
+            <a:off x="640080" y="2240280"/>
             <a:ext cx="640080" cy="640080"/>
           </a:xfrm>
           <a:prstGeom prst="rect">
@@ -2637,14 +2896,14 @@
       </p:sp>
       <p:sp>
         <p:nvSpPr>
-          <p:cNvPr id="9" name="Text 7"/>
-          <p:cNvSpPr/>
-          <p:nvPr/>
-        </p:nvSpPr>
-        <p:spPr>
-          <a:xfrm>
-            <a:off x="1463040" y="2560320"/>
-            <a:ext cx="3657600" cy="457200"/>
+          <p:cNvPr id="10" name="Text 8"/>
+          <p:cNvSpPr/>
+          <p:nvPr/>
+        </p:nvSpPr>
+        <p:spPr>
+          <a:xfrm>
+            <a:off x="1463040" y="2194560"/>
+            <a:ext cx="4572000" cy="365760"/>
           </a:xfrm>
           <a:prstGeom prst="rect">
             <a:avLst/>
@@ -2660,7 +2919,7 @@
               <a:buNone/>
             </a:pPr>
             <a:r>
-              <a:rPr lang="en-US" sz="1900" b="1" dirty="0">
+              <a:rPr lang="en-US" sz="1800" b="1" dirty="0">
                 <a:solidFill>
                   <a:srgbClr val="0B3D91"/>
                 </a:solidFill>
@@ -2668,22 +2927,22 @@
                 <a:ea typeface="Georgia" pitchFamily="34" charset="-122"/>
                 <a:cs typeface="Georgia" pitchFamily="34" charset="-120"/>
               </a:rPr>
-              <a:t>Qué solicitas</a:t>
-            </a:r>
-            <a:endParaRPr lang="en-US" sz="1900" dirty="0"/>
-          </a:p>
-        </p:txBody>
-      </p:sp>
-      <p:sp>
-        <p:nvSpPr>
-          <p:cNvPr id="10" name="Text 8"/>
-          <p:cNvSpPr/>
-          <p:nvPr/>
-        </p:nvSpPr>
-        <p:spPr>
-          <a:xfrm>
-            <a:off x="1463040" y="2971800"/>
-            <a:ext cx="4754880" cy="457200"/>
+              <a:t>Tus datos (RENIEC)</a:t>
+            </a:r>
+            <a:endParaRPr lang="en-US" sz="1800" dirty="0"/>
+          </a:p>
+        </p:txBody>
+      </p:sp>
+      <p:sp>
+        <p:nvSpPr>
+          <p:cNvPr id="11" name="Text 9"/>
+          <p:cNvSpPr/>
+          <p:nvPr/>
+        </p:nvSpPr>
+        <p:spPr>
+          <a:xfrm>
+            <a:off x="1463040" y="2560320"/>
+            <a:ext cx="4754880" cy="365760"/>
           </a:xfrm>
           <a:prstGeom prst="rect">
             <a:avLst/>
@@ -2699,7 +2958,7 @@
               <a:buNone/>
             </a:pPr>
             <a:r>
-              <a:rPr lang="en-US" sz="1400" dirty="0">
+              <a:rPr lang="en-US" sz="1300" dirty="0">
                 <a:solidFill>
                   <a:srgbClr val="566077"/>
                 </a:solidFill>
@@ -2707,21 +2966,21 @@
                 <a:ea typeface="Calibri" pitchFamily="34" charset="-122"/>
                 <a:cs typeface="Calibri" pitchFamily="34" charset="-120"/>
               </a:rPr>
-              <a:t>Describe la información pública que necesitas.</a:t>
-            </a:r>
-            <a:endParaRPr lang="en-US" sz="1400" dirty="0"/>
-          </a:p>
-        </p:txBody>
-      </p:sp>
-      <p:sp>
-        <p:nvSpPr>
-          <p:cNvPr id="11" name="Shape 9"/>
-          <p:cNvSpPr/>
-          <p:nvPr/>
-        </p:nvSpPr>
-        <p:spPr>
-          <a:xfrm>
-            <a:off x="640080" y="3657600"/>
+              <a:t>Autocompletado automático al ingresar tu DNI.</a:t>
+            </a:r>
+            <a:endParaRPr lang="en-US" sz="1300" dirty="0"/>
+          </a:p>
+        </p:txBody>
+      </p:sp>
+      <p:sp>
+        <p:nvSpPr>
+          <p:cNvPr id="12" name="Shape 10"/>
+          <p:cNvSpPr/>
+          <p:nvPr/>
+        </p:nvSpPr>
+        <p:spPr>
+          <a:xfrm>
+            <a:off x="640080" y="3246120"/>
             <a:ext cx="640080" cy="640080"/>
           </a:xfrm>
           <a:prstGeom prst="ellipse">
@@ -2735,13 +2994,13 @@
       </p:sp>
       <p:sp>
         <p:nvSpPr>
-          <p:cNvPr id="12" name="Text 10"/>
-          <p:cNvSpPr/>
-          <p:nvPr/>
-        </p:nvSpPr>
-        <p:spPr>
-          <a:xfrm>
-            <a:off x="640080" y="3657600"/>
+          <p:cNvPr id="13" name="Text 11"/>
+          <p:cNvSpPr/>
+          <p:nvPr/>
+        </p:nvSpPr>
+        <p:spPr>
+          <a:xfrm>
+            <a:off x="640080" y="3246120"/>
             <a:ext cx="640080" cy="640080"/>
           </a:xfrm>
           <a:prstGeom prst="rect">
@@ -2774,14 +3033,14 @@
       </p:sp>
       <p:sp>
         <p:nvSpPr>
-          <p:cNvPr id="13" name="Text 11"/>
-          <p:cNvSpPr/>
-          <p:nvPr/>
-        </p:nvSpPr>
-        <p:spPr>
-          <a:xfrm>
-            <a:off x="1463040" y="3611880"/>
-            <a:ext cx="3657600" cy="457200"/>
+          <p:cNvPr id="14" name="Text 12"/>
+          <p:cNvSpPr/>
+          <p:nvPr/>
+        </p:nvSpPr>
+        <p:spPr>
+          <a:xfrm>
+            <a:off x="1463040" y="3200400"/>
+            <a:ext cx="4572000" cy="365760"/>
           </a:xfrm>
           <a:prstGeom prst="rect">
             <a:avLst/>
@@ -2797,7 +3056,7 @@
               <a:buNone/>
             </a:pPr>
             <a:r>
-              <a:rPr lang="en-US" sz="1900" b="1" dirty="0">
+              <a:rPr lang="en-US" sz="1800" b="1" dirty="0">
                 <a:solidFill>
                   <a:srgbClr val="0B3D91"/>
                 </a:solidFill>
@@ -2805,22 +3064,22 @@
                 <a:ea typeface="Georgia" pitchFamily="34" charset="-122"/>
                 <a:cs typeface="Georgia" pitchFamily="34" charset="-120"/>
               </a:rPr>
-              <a:t>Forma de entrega</a:t>
-            </a:r>
-            <a:endParaRPr lang="en-US" sz="1900" dirty="0"/>
-          </a:p>
-        </p:txBody>
-      </p:sp>
-      <p:sp>
-        <p:nvSpPr>
-          <p:cNvPr id="14" name="Text 12"/>
-          <p:cNvSpPr/>
-          <p:nvPr/>
-        </p:nvSpPr>
-        <p:spPr>
-          <a:xfrm>
-            <a:off x="1463040" y="4023360"/>
-            <a:ext cx="4754880" cy="457200"/>
+              <a:t>Documento y Carga</a:t>
+            </a:r>
+            <a:endParaRPr lang="en-US" sz="1800" dirty="0"/>
+          </a:p>
+        </p:txBody>
+      </p:sp>
+      <p:sp>
+        <p:nvSpPr>
+          <p:cNvPr id="15" name="Text 13"/>
+          <p:cNvSpPr/>
+          <p:nvPr/>
+        </p:nvSpPr>
+        <p:spPr>
+          <a:xfrm>
+            <a:off x="1463040" y="3566160"/>
+            <a:ext cx="4754880" cy="365760"/>
           </a:xfrm>
           <a:prstGeom prst="rect">
             <a:avLst/>
@@ -2836,7 +3095,7 @@
               <a:buNone/>
             </a:pPr>
             <a:r>
-              <a:rPr lang="en-US" sz="1400" dirty="0">
+              <a:rPr lang="en-US" sz="1300" dirty="0">
                 <a:solidFill>
                   <a:srgbClr val="566077"/>
                 </a:solidFill>
@@ -2844,21 +3103,21 @@
                 <a:ea typeface="Calibri" pitchFamily="34" charset="-122"/>
                 <a:cs typeface="Calibri" pitchFamily="34" charset="-120"/>
               </a:rPr>
-              <a:t>Por correo o recojo presencial.</a:t>
-            </a:r>
-            <a:endParaRPr lang="en-US" sz="1400" dirty="0"/>
-          </a:p>
-        </p:txBody>
-      </p:sp>
-      <p:sp>
-        <p:nvSpPr>
-          <p:cNvPr id="15" name="Shape 13"/>
-          <p:cNvSpPr/>
-          <p:nvPr/>
-        </p:nvSpPr>
-        <p:spPr>
-          <a:xfrm>
-            <a:off x="640080" y="4709160"/>
+              <a:t>Asunto, folios y adjunto de sustento (PDF/JPG/PNG).</a:t>
+            </a:r>
+            <a:endParaRPr lang="en-US" sz="1300" dirty="0"/>
+          </a:p>
+        </p:txBody>
+      </p:sp>
+      <p:sp>
+        <p:nvSpPr>
+          <p:cNvPr id="16" name="Shape 14"/>
+          <p:cNvSpPr/>
+          <p:nvPr/>
+        </p:nvSpPr>
+        <p:spPr>
+          <a:xfrm>
+            <a:off x="640080" y="4251960"/>
             <a:ext cx="640080" cy="640080"/>
           </a:xfrm>
           <a:prstGeom prst="ellipse">
@@ -2872,13 +3131,13 @@
       </p:sp>
       <p:sp>
         <p:nvSpPr>
-          <p:cNvPr id="16" name="Text 14"/>
-          <p:cNvSpPr/>
-          <p:nvPr/>
-        </p:nvSpPr>
-        <p:spPr>
-          <a:xfrm>
-            <a:off x="640080" y="4709160"/>
+          <p:cNvPr id="17" name="Text 15"/>
+          <p:cNvSpPr/>
+          <p:nvPr/>
+        </p:nvSpPr>
+        <p:spPr>
+          <a:xfrm>
+            <a:off x="640080" y="4251960"/>
             <a:ext cx="640080" cy="640080"/>
           </a:xfrm>
           <a:prstGeom prst="rect">
@@ -2911,14 +3170,14 @@
       </p:sp>
       <p:sp>
         <p:nvSpPr>
-          <p:cNvPr id="17" name="Text 15"/>
-          <p:cNvSpPr/>
-          <p:nvPr/>
-        </p:nvSpPr>
-        <p:spPr>
-          <a:xfrm>
-            <a:off x="1463040" y="4663440"/>
-            <a:ext cx="3657600" cy="457200"/>
+          <p:cNvPr id="18" name="Text 16"/>
+          <p:cNvSpPr/>
+          <p:nvPr/>
+        </p:nvSpPr>
+        <p:spPr>
+          <a:xfrm>
+            <a:off x="1463040" y="4206240"/>
+            <a:ext cx="4572000" cy="365760"/>
           </a:xfrm>
           <a:prstGeom prst="rect">
             <a:avLst/>
@@ -2934,7 +3193,7 @@
               <a:buNone/>
             </a:pPr>
             <a:r>
-              <a:rPr lang="en-US" sz="1900" b="1" dirty="0">
+              <a:rPr lang="en-US" sz="1800" b="1" dirty="0">
                 <a:solidFill>
                   <a:srgbClr val="0B3D91"/>
                 </a:solidFill>
@@ -2942,22 +3201,22 @@
                 <a:ea typeface="Georgia" pitchFamily="34" charset="-122"/>
                 <a:cs typeface="Georgia" pitchFamily="34" charset="-120"/>
               </a:rPr>
-              <a:t>Confirmación</a:t>
-            </a:r>
-            <a:endParaRPr lang="en-US" sz="1900" dirty="0"/>
-          </a:p>
-        </p:txBody>
-      </p:sp>
-      <p:sp>
-        <p:nvSpPr>
-          <p:cNvPr id="18" name="Text 16"/>
-          <p:cNvSpPr/>
-          <p:nvPr/>
-        </p:nvSpPr>
-        <p:spPr>
-          <a:xfrm>
-            <a:off x="1463040" y="5074920"/>
-            <a:ext cx="4754880" cy="457200"/>
+              <a:t>Forma de entrega</a:t>
+            </a:r>
+            <a:endParaRPr lang="en-US" sz="1800" dirty="0"/>
+          </a:p>
+        </p:txBody>
+      </p:sp>
+      <p:sp>
+        <p:nvSpPr>
+          <p:cNvPr id="19" name="Text 17"/>
+          <p:cNvSpPr/>
+          <p:nvPr/>
+        </p:nvSpPr>
+        <p:spPr>
+          <a:xfrm>
+            <a:off x="1463040" y="4572000"/>
+            <a:ext cx="4754880" cy="365760"/>
           </a:xfrm>
           <a:prstGeom prst="rect">
             <a:avLst/>
@@ -2973,7 +3232,7 @@
               <a:buNone/>
             </a:pPr>
             <a:r>
-              <a:rPr lang="en-US" sz="1400" dirty="0">
+              <a:rPr lang="en-US" sz="1300" dirty="0">
                 <a:solidFill>
                   <a:srgbClr val="566077"/>
                 </a:solidFill>
@@ -2981,26 +3240,163 @@
                 <a:ea typeface="Calibri" pitchFamily="34" charset="-122"/>
                 <a:cs typeface="Calibri" pitchFamily="34" charset="-120"/>
               </a:rPr>
-              <a:t>Recibe tu número de expediente.</a:t>
-            </a:r>
-            <a:endParaRPr lang="en-US" sz="1400" dirty="0"/>
-          </a:p>
-        </p:txBody>
-      </p:sp>
-      <p:sp>
-        <p:nvSpPr>
-          <p:cNvPr id="19" name="Shape 17"/>
-          <p:cNvSpPr/>
-          <p:nvPr/>
-        </p:nvSpPr>
-        <p:spPr>
-          <a:xfrm>
-            <a:off x="6766560" y="1554480"/>
-            <a:ext cx="4754880" cy="4023360"/>
+              <a:t>Por correo electrónico o recojo presencial.</a:t>
+            </a:r>
+            <a:endParaRPr lang="en-US" sz="1300" dirty="0"/>
+          </a:p>
+        </p:txBody>
+      </p:sp>
+      <p:sp>
+        <p:nvSpPr>
+          <p:cNvPr id="20" name="Shape 18"/>
+          <p:cNvSpPr/>
+          <p:nvPr/>
+        </p:nvSpPr>
+        <p:spPr>
+          <a:xfrm>
+            <a:off x="640080" y="5257800"/>
+            <a:ext cx="640080" cy="640080"/>
+          </a:xfrm>
+          <a:prstGeom prst="ellipse">
+            <a:avLst/>
+          </a:prstGeom>
+          <a:solidFill>
+            <a:srgbClr val="0B3D91"/>
+          </a:solidFill>
+          <a:ln/>
+        </p:spPr>
+      </p:sp>
+      <p:sp>
+        <p:nvSpPr>
+          <p:cNvPr id="21" name="Text 19"/>
+          <p:cNvSpPr/>
+          <p:nvPr/>
+        </p:nvSpPr>
+        <p:spPr>
+          <a:xfrm>
+            <a:off x="640080" y="5257800"/>
+            <a:ext cx="640080" cy="640080"/>
+          </a:xfrm>
+          <a:prstGeom prst="rect">
+            <a:avLst/>
+          </a:prstGeom>
+          <a:noFill/>
+          <a:ln/>
+        </p:spPr>
+        <p:txBody>
+          <a:bodyPr wrap="square" rtlCol="0" anchor="ctr"/>
+          <a:lstStyle/>
+          <a:p>
+            <a:pPr algn="ctr" indent="0" marL="0">
+              <a:buNone/>
+            </a:pPr>
+            <a:r>
+              <a:rPr lang="en-US" sz="2400" b="1" dirty="0">
+                <a:solidFill>
+                  <a:srgbClr val="FFFFFF"/>
+                </a:solidFill>
+                <a:latin typeface="Georgia" pitchFamily="34" charset="0"/>
+                <a:ea typeface="Georgia" pitchFamily="34" charset="-122"/>
+                <a:cs typeface="Georgia" pitchFamily="34" charset="-120"/>
+              </a:rPr>
+              <a:t>5</a:t>
+            </a:r>
+            <a:endParaRPr lang="en-US" sz="2400" dirty="0"/>
+          </a:p>
+        </p:txBody>
+      </p:sp>
+      <p:sp>
+        <p:nvSpPr>
+          <p:cNvPr id="22" name="Text 20"/>
+          <p:cNvSpPr/>
+          <p:nvPr/>
+        </p:nvSpPr>
+        <p:spPr>
+          <a:xfrm>
+            <a:off x="1463040" y="5212080"/>
+            <a:ext cx="4572000" cy="365760"/>
+          </a:xfrm>
+          <a:prstGeom prst="rect">
+            <a:avLst/>
+          </a:prstGeom>
+          <a:noFill/>
+          <a:ln/>
+        </p:spPr>
+        <p:txBody>
+          <a:bodyPr wrap="square" rtlCol="0" anchor="ctr"/>
+          <a:lstStyle/>
+          <a:p>
+            <a:pPr indent="0" marL="0">
+              <a:buNone/>
+            </a:pPr>
+            <a:r>
+              <a:rPr lang="en-US" sz="1800" b="1" dirty="0">
+                <a:solidFill>
+                  <a:srgbClr val="0B3D91"/>
+                </a:solidFill>
+                <a:latin typeface="Georgia" pitchFamily="34" charset="0"/>
+                <a:ea typeface="Georgia" pitchFamily="34" charset="-122"/>
+                <a:cs typeface="Georgia" pitchFamily="34" charset="-120"/>
+              </a:rPr>
+              <a:t>Confirmación</a:t>
+            </a:r>
+            <a:endParaRPr lang="en-US" sz="1800" dirty="0"/>
+          </a:p>
+        </p:txBody>
+      </p:sp>
+      <p:sp>
+        <p:nvSpPr>
+          <p:cNvPr id="23" name="Text 21"/>
+          <p:cNvSpPr/>
+          <p:nvPr/>
+        </p:nvSpPr>
+        <p:spPr>
+          <a:xfrm>
+            <a:off x="1463040" y="5577840"/>
+            <a:ext cx="4754880" cy="365760"/>
+          </a:xfrm>
+          <a:prstGeom prst="rect">
+            <a:avLst/>
+          </a:prstGeom>
+          <a:noFill/>
+          <a:ln/>
+        </p:spPr>
+        <p:txBody>
+          <a:bodyPr wrap="square" rtlCol="0" anchor="ctr"/>
+          <a:lstStyle/>
+          <a:p>
+            <a:pPr indent="0" marL="0">
+              <a:buNone/>
+            </a:pPr>
+            <a:r>
+              <a:rPr lang="en-US" sz="1300" dirty="0">
+                <a:solidFill>
+                  <a:srgbClr val="566077"/>
+                </a:solidFill>
+                <a:latin typeface="Calibri" pitchFamily="34" charset="0"/>
+                <a:ea typeface="Calibri" pitchFamily="34" charset="-122"/>
+                <a:cs typeface="Calibri" pitchFamily="34" charset="-120"/>
+              </a:rPr>
+              <a:t>Revisión final y generación de número de expediente.</a:t>
+            </a:r>
+            <a:endParaRPr lang="en-US" sz="1300" dirty="0"/>
+          </a:p>
+        </p:txBody>
+      </p:sp>
+      <p:sp>
+        <p:nvSpPr>
+          <p:cNvPr id="24" name="Shape 22"/>
+          <p:cNvSpPr/>
+          <p:nvPr/>
+        </p:nvSpPr>
+        <p:spPr>
+          <a:xfrm>
+            <a:off x="6766560" y="1234440"/>
+            <a:ext cx="4754880" cy="4663440"/>
           </a:xfrm>
           <a:prstGeom prst="roundRect">
             <a:avLst>
-              <a:gd name="adj" fmla="val 2727"/>
+              <a:gd name="adj" fmla="val 2353"/>
             </a:avLst>
           </a:prstGeom>
           <a:solidFill>
@@ -3016,14 +3412,14 @@
       </p:sp>
       <p:sp>
         <p:nvSpPr>
-          <p:cNvPr id="20" name="Text 18"/>
-          <p:cNvSpPr/>
-          <p:nvPr/>
-        </p:nvSpPr>
-        <p:spPr>
-          <a:xfrm>
-            <a:off x="7040880" y="1828800"/>
-            <a:ext cx="4206240" cy="3474720"/>
+          <p:cNvPr id="25" name="Text 23"/>
+          <p:cNvSpPr/>
+          <p:nvPr/>
+        </p:nvSpPr>
+        <p:spPr>
+          <a:xfrm>
+            <a:off x="7040880" y="1463040"/>
+            <a:ext cx="4206240" cy="4206240"/>
           </a:xfrm>
           <a:prstGeom prst="rect">
             <a:avLst/>
@@ -3060,7 +3456,7 @@
               <a:buNone/>
             </a:pPr>
             <a:r>
-              <a:rPr lang="en-US" sz="1500" dirty="0">
+              <a:rPr lang="en-US" sz="1350" dirty="0">
                 <a:solidFill>
                   <a:srgbClr val="1A1A1A"/>
                 </a:solidFill>
@@ -3068,7 +3464,7 @@
                 <a:ea typeface="Calibri" pitchFamily="34" charset="-122"/>
                 <a:cs typeface="Calibri" pitchFamily="34" charset="-120"/>
               </a:rPr>
-              <a:t>🗂️  Casillero electrónico: ve tus solicitudes
+              <a:t>🔐  Casillero Electrónico: bandeja ciudadana accesible con historial y notificaciones oficiales.
 </a:t>
             </a:r>
             <a:pPr indent="0" marL="0">
@@ -3078,7 +3474,7 @@
               <a:buNone/>
             </a:pPr>
             <a:r>
-              <a:rPr lang="en-US" sz="1500" dirty="0">
+              <a:rPr lang="en-US" sz="1350" dirty="0">
                 <a:solidFill>
                   <a:srgbClr val="1A1A1A"/>
                 </a:solidFill>
@@ -3086,7 +3482,7 @@
                 <a:ea typeface="Calibri" pitchFamily="34" charset="-122"/>
                 <a:cs typeface="Calibri" pitchFamily="34" charset="-120"/>
               </a:rPr>
-              <a:t>🔊  Modo voz: la app lee sola, sin instalar nada
+              <a:t>🎙️  Comandos de voz en español (mejora manos libres)
 </a:t>
             </a:r>
             <a:pPr indent="0" marL="0">
@@ -3096,7 +3492,7 @@
               <a:buNone/>
             </a:pPr>
             <a:r>
-              <a:rPr lang="en-US" sz="1500" dirty="0">
+              <a:rPr lang="en-US" sz="1350" dirty="0">
                 <a:solidFill>
                   <a:srgbClr val="1A1A1A"/>
                 </a:solidFill>
@@ -3104,7 +3500,7 @@
                 <a:ea typeface="Calibri" pitchFamily="34" charset="-122"/>
                 <a:cs typeface="Calibri" pitchFamily="34" charset="-120"/>
               </a:rPr>
-              <a:t>🎙️  Comandos de voz en español (manos libres)
+              <a:t>🗣️  Audio de apoyo en quechua por cada paso del asistente
 </a:t>
             </a:r>
             <a:pPr indent="0" marL="0">
@@ -3114,7 +3510,7 @@
               <a:buNone/>
             </a:pPr>
             <a:r>
-              <a:rPr lang="en-US" sz="1500" dirty="0">
+              <a:rPr lang="en-US" sz="1350" dirty="0">
                 <a:solidFill>
                   <a:srgbClr val="1A1A1A"/>
                 </a:solidFill>
@@ -3122,9 +3518,9 @@
                 <a:ea typeface="Calibri" pitchFamily="34" charset="-122"/>
                 <a:cs typeface="Calibri" pitchFamily="34" charset="-120"/>
               </a:rPr>
-              <a:t>📱  App instalable (PWA) que funciona offline</a:t>
-            </a:r>
-            <a:endParaRPr lang="en-US" sz="1500" dirty="0"/>
+              <a:t>⚠️  Identificación de errores accesible (resumen y foco programado)</a:t>
+            </a:r>
+            <a:endParaRPr lang="en-US" sz="1350" dirty="0"/>
           </a:p>
         </p:txBody>
       </p:sp>
@@ -3168,8 +3564,8 @@
         </p:nvSpPr>
         <p:spPr>
           <a:xfrm>
-            <a:off x="640080" y="457200"/>
-            <a:ext cx="10908792" cy="822960"/>
+            <a:off x="640080" y="365760"/>
+            <a:ext cx="10908792" cy="731520"/>
           </a:xfrm>
           <a:prstGeom prst="rect">
             <a:avLst/>
@@ -3185,7 +3581,7 @@
               <a:buNone/>
             </a:pPr>
             <a:r>
-              <a:rPr lang="en-US" sz="3400" b="1" dirty="0">
+              <a:rPr lang="en-US" sz="3200" b="1" dirty="0">
                 <a:solidFill>
                   <a:srgbClr val="0B3D91"/>
                 </a:solidFill>
@@ -3193,9 +3589,9 @@
                 <a:ea typeface="Georgia" pitchFamily="34" charset="-122"/>
                 <a:cs typeface="Georgia" pitchFamily="34" charset="-120"/>
               </a:rPr>
-              <a:t>Valor público</a:t>
-            </a:r>
-            <a:endParaRPr lang="en-US" sz="3400" dirty="0"/>
+              <a:t>Interfaz del Prototipo</a:t>
+            </a:r>
+            <a:endParaRPr lang="en-US" sz="3200" dirty="0"/>
           </a:p>
         </p:txBody>
       </p:sp>
@@ -3207,12 +3603,32 @@
         </p:nvSpPr>
         <p:spPr>
           <a:xfrm>
-            <a:off x="640080" y="1645920"/>
-            <a:ext cx="5303520" cy="1828800"/>
+            <a:off x="640080" y="1051560"/>
+            <a:ext cx="1097280" cy="45720"/>
+          </a:xfrm>
+          <a:prstGeom prst="rect">
+            <a:avLst/>
+          </a:prstGeom>
+          <a:solidFill>
+            <a:srgbClr val="E0A100"/>
+          </a:solidFill>
+          <a:ln/>
+        </p:spPr>
+      </p:sp>
+      <p:sp>
+        <p:nvSpPr>
+          <p:cNvPr id="4" name="Shape 2"/>
+          <p:cNvSpPr/>
+          <p:nvPr/>
+        </p:nvSpPr>
+        <p:spPr>
+          <a:xfrm>
+            <a:off x="640080" y="1463040"/>
+            <a:ext cx="5120640" cy="4663440"/>
           </a:xfrm>
           <a:prstGeom prst="roundRect">
             <a:avLst>
-              <a:gd name="adj" fmla="val 6000"/>
+              <a:gd name="adj" fmla="val 2353"/>
             </a:avLst>
           </a:prstGeom>
           <a:solidFill>
@@ -3221,16 +3637,40 @@
           <a:ln/>
         </p:spPr>
       </p:sp>
-      <p:sp>
-        <p:nvSpPr>
-          <p:cNvPr id="4" name="Text 2"/>
-          <p:cNvSpPr/>
-          <p:nvPr/>
-        </p:nvSpPr>
-        <p:spPr>
-          <a:xfrm>
-            <a:off x="914400" y="1874520"/>
-            <a:ext cx="4754880" cy="548640"/>
+      <p:pic>
+        <p:nvPicPr>
+          <p:cNvPr id="5" name="Image 0" descr="screenshot1.png">    </p:cNvPr>
+          <p:cNvPicPr>
+            <a:picLocks noChangeAspect="1"/>
+          </p:cNvPicPr>
+          <p:nvPr/>
+        </p:nvPicPr>
+        <p:blipFill>
+          <a:blip r:embed="rId1"/>
+          <a:stretch>
+            <a:fillRect/>
+          </a:stretch>
+        </p:blipFill>
+        <p:spPr>
+          <a:xfrm>
+            <a:off x="914400" y="1737360"/>
+            <a:ext cx="4572000" cy="3200400"/>
+          </a:xfrm>
+          <a:prstGeom prst="rect">
+            <a:avLst/>
+          </a:prstGeom>
+        </p:spPr>
+      </p:pic>
+      <p:sp>
+        <p:nvSpPr>
+          <p:cNvPr id="6" name="Text 3"/>
+          <p:cNvSpPr/>
+          <p:nvPr/>
+        </p:nvSpPr>
+        <p:spPr>
+          <a:xfrm>
+            <a:off x="640080" y="5120640"/>
+            <a:ext cx="5120640" cy="822960"/>
           </a:xfrm>
           <a:prstGeom prst="rect">
             <a:avLst/>
@@ -3242,50 +3682,11 @@
           <a:bodyPr wrap="square" rtlCol="0" anchor="ctr"/>
           <a:lstStyle/>
           <a:p>
-            <a:pPr indent="0" marL="0">
-              <a:buNone/>
-            </a:pPr>
-            <a:r>
-              <a:rPr lang="en-US" sz="2200" b="1" dirty="0">
-                <a:solidFill>
-                  <a:srgbClr val="0B3D91"/>
-                </a:solidFill>
-                <a:latin typeface="Georgia" pitchFamily="34" charset="0"/>
-                <a:ea typeface="Georgia" pitchFamily="34" charset="-122"/>
-                <a:cs typeface="Georgia" pitchFamily="34" charset="-120"/>
-              </a:rPr>
-              <a:t>Autonomía</a:t>
-            </a:r>
-            <a:endParaRPr lang="en-US" sz="2200" dirty="0"/>
-          </a:p>
-        </p:txBody>
-      </p:sp>
-      <p:sp>
-        <p:nvSpPr>
-          <p:cNvPr id="5" name="Text 3"/>
-          <p:cNvSpPr/>
-          <p:nvPr/>
-        </p:nvSpPr>
-        <p:spPr>
-          <a:xfrm>
-            <a:off x="914400" y="2514600"/>
-            <a:ext cx="4754880" cy="822960"/>
-          </a:xfrm>
-          <a:prstGeom prst="rect">
-            <a:avLst/>
-          </a:prstGeom>
-          <a:noFill/>
-          <a:ln/>
-        </p:spPr>
-        <p:txBody>
-          <a:bodyPr wrap="square" rtlCol="0" anchor="ctr"/>
-          <a:lstStyle/>
-          <a:p>
-            <a:pPr indent="0" marL="0">
-              <a:buNone/>
-            </a:pPr>
-            <a:r>
-              <a:rPr lang="en-US" sz="1600" dirty="0">
+            <a:pPr algn="ctr" indent="0" marL="0">
+              <a:buNone/>
+            </a:pPr>
+            <a:r>
+              <a:rPr lang="en-US" sz="1400" b="1" dirty="0">
                 <a:solidFill>
                   <a:srgbClr val="1A1A1A"/>
                 </a:solidFill>
@@ -3293,26 +3694,26 @@
                 <a:ea typeface="Calibri" pitchFamily="34" charset="-122"/>
                 <a:cs typeface="Calibri" pitchFamily="34" charset="-120"/>
               </a:rPr>
-              <a:t>Hacen trámites sin depender de nadie.</a:t>
-            </a:r>
-            <a:endParaRPr lang="en-US" sz="1600" dirty="0"/>
-          </a:p>
-        </p:txBody>
-      </p:sp>
-      <p:sp>
-        <p:nvSpPr>
-          <p:cNvPr id="6" name="Shape 4"/>
-          <p:cNvSpPr/>
-          <p:nvPr/>
-        </p:nvSpPr>
-        <p:spPr>
-          <a:xfrm>
-            <a:off x="6217920" y="1645920"/>
-            <a:ext cx="5303520" cy="1828800"/>
+              <a:t>Pantalla de inicio y Casillero Electrónico accesible.</a:t>
+            </a:r>
+            <a:endParaRPr lang="en-US" sz="1400" dirty="0"/>
+          </a:p>
+        </p:txBody>
+      </p:sp>
+      <p:sp>
+        <p:nvSpPr>
+          <p:cNvPr id="7" name="Shape 4"/>
+          <p:cNvSpPr/>
+          <p:nvPr/>
+        </p:nvSpPr>
+        <p:spPr>
+          <a:xfrm>
+            <a:off x="6400800" y="1463040"/>
+            <a:ext cx="5120640" cy="4663440"/>
           </a:xfrm>
           <a:prstGeom prst="roundRect">
             <a:avLst>
-              <a:gd name="adj" fmla="val 6000"/>
+              <a:gd name="adj" fmla="val 2353"/>
             </a:avLst>
           </a:prstGeom>
           <a:solidFill>
@@ -3321,16 +3722,40 @@
           <a:ln/>
         </p:spPr>
       </p:sp>
-      <p:sp>
-        <p:nvSpPr>
-          <p:cNvPr id="7" name="Text 5"/>
-          <p:cNvSpPr/>
-          <p:nvPr/>
-        </p:nvSpPr>
-        <p:spPr>
-          <a:xfrm>
-            <a:off x="6492240" y="1874520"/>
-            <a:ext cx="4754880" cy="548640"/>
+      <p:pic>
+        <p:nvPicPr>
+          <p:cNvPr id="8" name="Image 1" descr="screenshot2.png">    </p:cNvPr>
+          <p:cNvPicPr>
+            <a:picLocks noChangeAspect="1"/>
+          </p:cNvPicPr>
+          <p:nvPr/>
+        </p:nvPicPr>
+        <p:blipFill>
+          <a:blip r:embed="rId2"/>
+          <a:stretch>
+            <a:fillRect/>
+          </a:stretch>
+        </p:blipFill>
+        <p:spPr>
+          <a:xfrm>
+            <a:off x="6675120" y="1737360"/>
+            <a:ext cx="4572000" cy="3200400"/>
+          </a:xfrm>
+          <a:prstGeom prst="rect">
+            <a:avLst/>
+          </a:prstGeom>
+        </p:spPr>
+      </p:pic>
+      <p:sp>
+        <p:nvSpPr>
+          <p:cNvPr id="9" name="Text 5"/>
+          <p:cNvSpPr/>
+          <p:nvPr/>
+        </p:nvSpPr>
+        <p:spPr>
+          <a:xfrm>
+            <a:off x="6400800" y="5120640"/>
+            <a:ext cx="5120640" cy="822960"/>
           </a:xfrm>
           <a:prstGeom prst="rect">
             <a:avLst/>
@@ -3342,50 +3767,11 @@
           <a:bodyPr wrap="square" rtlCol="0" anchor="ctr"/>
           <a:lstStyle/>
           <a:p>
-            <a:pPr indent="0" marL="0">
-              <a:buNone/>
-            </a:pPr>
-            <a:r>
-              <a:rPr lang="en-US" sz="2200" b="1" dirty="0">
-                <a:solidFill>
-                  <a:srgbClr val="0B3D91"/>
-                </a:solidFill>
-                <a:latin typeface="Georgia" pitchFamily="34" charset="0"/>
-                <a:ea typeface="Georgia" pitchFamily="34" charset="-122"/>
-                <a:cs typeface="Georgia" pitchFamily="34" charset="-120"/>
-              </a:rPr>
-              <a:t>Privacidad</a:t>
-            </a:r>
-            <a:endParaRPr lang="en-US" sz="2200" dirty="0"/>
-          </a:p>
-        </p:txBody>
-      </p:sp>
-      <p:sp>
-        <p:nvSpPr>
-          <p:cNvPr id="8" name="Text 6"/>
-          <p:cNvSpPr/>
-          <p:nvPr/>
-        </p:nvSpPr>
-        <p:spPr>
-          <a:xfrm>
-            <a:off x="6492240" y="2514600"/>
-            <a:ext cx="4754880" cy="822960"/>
-          </a:xfrm>
-          <a:prstGeom prst="rect">
-            <a:avLst/>
-          </a:prstGeom>
-          <a:noFill/>
-          <a:ln/>
-        </p:spPr>
-        <p:txBody>
-          <a:bodyPr wrap="square" rtlCol="0" anchor="ctr"/>
-          <a:lstStyle/>
-          <a:p>
-            <a:pPr indent="0" marL="0">
-              <a:buNone/>
-            </a:pPr>
-            <a:r>
-              <a:rPr lang="en-US" sz="1600" dirty="0">
+            <a:pPr algn="ctr" indent="0" marL="0">
+              <a:buNone/>
+            </a:pPr>
+            <a:r>
+              <a:rPr lang="en-US" sz="1400" b="1" dirty="0">
                 <a:solidFill>
                   <a:srgbClr val="1A1A1A"/>
                 </a:solidFill>
@@ -3393,209 +3779,9 @@
                 <a:ea typeface="Calibri" pitchFamily="34" charset="-122"/>
                 <a:cs typeface="Calibri" pitchFamily="34" charset="-120"/>
               </a:rPr>
-              <a:t>Sus datos no salen del dispositivo.</a:t>
-            </a:r>
-            <a:endParaRPr lang="en-US" sz="1600" dirty="0"/>
-          </a:p>
-        </p:txBody>
-      </p:sp>
-      <p:sp>
-        <p:nvSpPr>
-          <p:cNvPr id="9" name="Shape 7"/>
-          <p:cNvSpPr/>
-          <p:nvPr/>
-        </p:nvSpPr>
-        <p:spPr>
-          <a:xfrm>
-            <a:off x="640080" y="3749040"/>
-            <a:ext cx="5303520" cy="1828800"/>
-          </a:xfrm>
-          <a:prstGeom prst="roundRect">
-            <a:avLst>
-              <a:gd name="adj" fmla="val 6000"/>
-            </a:avLst>
-          </a:prstGeom>
-          <a:solidFill>
-            <a:srgbClr val="F2F5FB"/>
-          </a:solidFill>
-          <a:ln/>
-        </p:spPr>
-      </p:sp>
-      <p:sp>
-        <p:nvSpPr>
-          <p:cNvPr id="10" name="Text 8"/>
-          <p:cNvSpPr/>
-          <p:nvPr/>
-        </p:nvSpPr>
-        <p:spPr>
-          <a:xfrm>
-            <a:off x="914400" y="3977640"/>
-            <a:ext cx="4754880" cy="548640"/>
-          </a:xfrm>
-          <a:prstGeom prst="rect">
-            <a:avLst/>
-          </a:prstGeom>
-          <a:noFill/>
-          <a:ln/>
-        </p:spPr>
-        <p:txBody>
-          <a:bodyPr wrap="square" rtlCol="0" anchor="ctr"/>
-          <a:lstStyle/>
-          <a:p>
-            <a:pPr indent="0" marL="0">
-              <a:buNone/>
-            </a:pPr>
-            <a:r>
-              <a:rPr lang="en-US" sz="2200" b="1" dirty="0">
-                <a:solidFill>
-                  <a:srgbClr val="0B3D91"/>
-                </a:solidFill>
-                <a:latin typeface="Georgia" pitchFamily="34" charset="0"/>
-                <a:ea typeface="Georgia" pitchFamily="34" charset="-122"/>
-                <a:cs typeface="Georgia" pitchFamily="34" charset="-120"/>
-              </a:rPr>
-              <a:t>Inclusión</a:t>
-            </a:r>
-            <a:endParaRPr lang="en-US" sz="2200" dirty="0"/>
-          </a:p>
-        </p:txBody>
-      </p:sp>
-      <p:sp>
-        <p:nvSpPr>
-          <p:cNvPr id="11" name="Text 9"/>
-          <p:cNvSpPr/>
-          <p:nvPr/>
-        </p:nvSpPr>
-        <p:spPr>
-          <a:xfrm>
-            <a:off x="914400" y="4617720"/>
-            <a:ext cx="4754880" cy="822960"/>
-          </a:xfrm>
-          <a:prstGeom prst="rect">
-            <a:avLst/>
-          </a:prstGeom>
-          <a:noFill/>
-          <a:ln/>
-        </p:spPr>
-        <p:txBody>
-          <a:bodyPr wrap="square" rtlCol="0" anchor="ctr"/>
-          <a:lstStyle/>
-          <a:p>
-            <a:pPr indent="0" marL="0">
-              <a:buNone/>
-            </a:pPr>
-            <a:r>
-              <a:rPr lang="en-US" sz="1600" dirty="0">
-                <a:solidFill>
-                  <a:srgbClr val="1A1A1A"/>
-                </a:solidFill>
-                <a:latin typeface="Calibri" pitchFamily="34" charset="0"/>
-                <a:ea typeface="Calibri" pitchFamily="34" charset="-122"/>
-                <a:cs typeface="Calibri" pitchFamily="34" charset="-120"/>
-              </a:rPr>
-              <a:t>Pensado también para hablantes de quechua.</a:t>
-            </a:r>
-            <a:endParaRPr lang="en-US" sz="1600" dirty="0"/>
-          </a:p>
-        </p:txBody>
-      </p:sp>
-      <p:sp>
-        <p:nvSpPr>
-          <p:cNvPr id="12" name="Shape 10"/>
-          <p:cNvSpPr/>
-          <p:nvPr/>
-        </p:nvSpPr>
-        <p:spPr>
-          <a:xfrm>
-            <a:off x="6217920" y="3749040"/>
-            <a:ext cx="5303520" cy="1828800"/>
-          </a:xfrm>
-          <a:prstGeom prst="roundRect">
-            <a:avLst>
-              <a:gd name="adj" fmla="val 6000"/>
-            </a:avLst>
-          </a:prstGeom>
-          <a:solidFill>
-            <a:srgbClr val="F2F5FB"/>
-          </a:solidFill>
-          <a:ln/>
-        </p:spPr>
-      </p:sp>
-      <p:sp>
-        <p:nvSpPr>
-          <p:cNvPr id="13" name="Text 11"/>
-          <p:cNvSpPr/>
-          <p:nvPr/>
-        </p:nvSpPr>
-        <p:spPr>
-          <a:xfrm>
-            <a:off x="6492240" y="3977640"/>
-            <a:ext cx="4754880" cy="548640"/>
-          </a:xfrm>
-          <a:prstGeom prst="rect">
-            <a:avLst/>
-          </a:prstGeom>
-          <a:noFill/>
-          <a:ln/>
-        </p:spPr>
-        <p:txBody>
-          <a:bodyPr wrap="square" rtlCol="0" anchor="ctr"/>
-          <a:lstStyle/>
-          <a:p>
-            <a:pPr indent="0" marL="0">
-              <a:buNone/>
-            </a:pPr>
-            <a:r>
-              <a:rPr lang="en-US" sz="2200" b="1" dirty="0">
-                <a:solidFill>
-                  <a:srgbClr val="0B3D91"/>
-                </a:solidFill>
-                <a:latin typeface="Georgia" pitchFamily="34" charset="0"/>
-                <a:ea typeface="Georgia" pitchFamily="34" charset="-122"/>
-                <a:cs typeface="Georgia" pitchFamily="34" charset="-120"/>
-              </a:rPr>
-              <a:t>Transparencia</a:t>
-            </a:r>
-            <a:endParaRPr lang="en-US" sz="2200" dirty="0"/>
-          </a:p>
-        </p:txBody>
-      </p:sp>
-      <p:sp>
-        <p:nvSpPr>
-          <p:cNvPr id="14" name="Text 12"/>
-          <p:cNvSpPr/>
-          <p:nvPr/>
-        </p:nvSpPr>
-        <p:spPr>
-          <a:xfrm>
-            <a:off x="6492240" y="4617720"/>
-            <a:ext cx="4754880" cy="822960"/>
-          </a:xfrm>
-          <a:prstGeom prst="rect">
-            <a:avLst/>
-          </a:prstGeom>
-          <a:noFill/>
-          <a:ln/>
-        </p:spPr>
-        <p:txBody>
-          <a:bodyPr wrap="square" rtlCol="0" anchor="ctr"/>
-          <a:lstStyle/>
-          <a:p>
-            <a:pPr indent="0" marL="0">
-              <a:buNone/>
-            </a:pPr>
-            <a:r>
-              <a:rPr lang="en-US" sz="1600" dirty="0">
-                <a:solidFill>
-                  <a:srgbClr val="1A1A1A"/>
-                </a:solidFill>
-                <a:latin typeface="Calibri" pitchFamily="34" charset="0"/>
-                <a:ea typeface="Calibri" pitchFamily="34" charset="-122"/>
-                <a:cs typeface="Calibri" pitchFamily="34" charset="-120"/>
-              </a:rPr>
-              <a:t>Garantiza el derecho a la información pública.</a:t>
-            </a:r>
-            <a:endParaRPr lang="en-US" sz="1600" dirty="0"/>
+              <a:t>Asistente conversacional con soporte de voz y audio en quechua.</a:t>
+            </a:r>
+            <a:endParaRPr lang="en-US" sz="1400" dirty="0"/>
           </a:p>
         </p:txBody>
       </p:sp>
@@ -3639,8 +3825,8 @@
         </p:nvSpPr>
         <p:spPr>
           <a:xfrm>
-            <a:off x="640080" y="457200"/>
-            <a:ext cx="10908792" cy="822960"/>
+            <a:off x="640080" y="365760"/>
+            <a:ext cx="10908792" cy="731520"/>
           </a:xfrm>
           <a:prstGeom prst="rect">
             <a:avLst/>
@@ -3656,7 +3842,7 @@
               <a:buNone/>
             </a:pPr>
             <a:r>
-              <a:rPr lang="en-US" sz="3400" b="1" dirty="0">
+              <a:rPr lang="en-US" sz="3200" b="1" dirty="0">
                 <a:solidFill>
                   <a:srgbClr val="0B3D91"/>
                 </a:solidFill>
@@ -3664,22 +3850,64 @@
                 <a:ea typeface="Georgia" pitchFamily="34" charset="-122"/>
                 <a:cs typeface="Georgia" pitchFamily="34" charset="-120"/>
               </a:rPr>
-              <a:t>Apertura, reutilización y ética</a:t>
-            </a:r>
-            <a:endParaRPr lang="en-US" sz="3400" dirty="0"/>
-          </a:p>
-        </p:txBody>
-      </p:sp>
-      <p:sp>
-        <p:nvSpPr>
-          <p:cNvPr id="3" name="Text 1"/>
+              <a:t>Valor público</a:t>
+            </a:r>
+            <a:endParaRPr lang="en-US" sz="3200" dirty="0"/>
+          </a:p>
+        </p:txBody>
+      </p:sp>
+      <p:sp>
+        <p:nvSpPr>
+          <p:cNvPr id="3" name="Shape 1"/>
+          <p:cNvSpPr/>
+          <p:nvPr/>
+        </p:nvSpPr>
+        <p:spPr>
+          <a:xfrm>
+            <a:off x="640080" y="1051560"/>
+            <a:ext cx="1097280" cy="45720"/>
+          </a:xfrm>
+          <a:prstGeom prst="rect">
+            <a:avLst/>
+          </a:prstGeom>
+          <a:solidFill>
+            <a:srgbClr val="E0A100"/>
+          </a:solidFill>
+          <a:ln/>
+        </p:spPr>
+      </p:sp>
+      <p:sp>
+        <p:nvSpPr>
+          <p:cNvPr id="4" name="Shape 2"/>
           <p:cNvSpPr/>
           <p:nvPr/>
         </p:nvSpPr>
         <p:spPr>
           <a:xfrm>
             <a:off x="640080" y="1645920"/>
-            <a:ext cx="10881360" cy="4114800"/>
+            <a:ext cx="5303520" cy="1828800"/>
+          </a:xfrm>
+          <a:prstGeom prst="roundRect">
+            <a:avLst>
+              <a:gd name="adj" fmla="val 6000"/>
+            </a:avLst>
+          </a:prstGeom>
+          <a:solidFill>
+            <a:srgbClr val="F2F5FB"/>
+          </a:solidFill>
+          <a:ln/>
+        </p:spPr>
+      </p:sp>
+      <p:sp>
+        <p:nvSpPr>
+          <p:cNvPr id="5" name="Text 3"/>
+          <p:cNvSpPr/>
+          <p:nvPr/>
+        </p:nvSpPr>
+        <p:spPr>
+          <a:xfrm>
+            <a:off x="914400" y="1874520"/>
+            <a:ext cx="4754880" cy="548640"/>
           </a:xfrm>
           <a:prstGeom prst="rect">
             <a:avLst/>
@@ -3692,13 +3920,49 @@
           <a:lstStyle/>
           <a:p>
             <a:pPr indent="0" marL="0">
-              <a:lnSpc>
-                <a:spcPct val="110000"/>
-              </a:lnSpc>
-              <a:buNone/>
-            </a:pPr>
-            <a:r>
-              <a:rPr lang="en-US" sz="2000" b="1" dirty="0">
+              <a:buNone/>
+            </a:pPr>
+            <a:r>
+              <a:rPr lang="en-US" sz="2200" b="1" dirty="0">
+                <a:solidFill>
+                  <a:srgbClr val="0B3D91"/>
+                </a:solidFill>
+                <a:latin typeface="Georgia" pitchFamily="34" charset="0"/>
+                <a:ea typeface="Georgia" pitchFamily="34" charset="-122"/>
+                <a:cs typeface="Georgia" pitchFamily="34" charset="-120"/>
+              </a:rPr>
+              <a:t>Autonomía</a:t>
+            </a:r>
+            <a:endParaRPr lang="en-US" sz="2200" dirty="0"/>
+          </a:p>
+        </p:txBody>
+      </p:sp>
+      <p:sp>
+        <p:nvSpPr>
+          <p:cNvPr id="6" name="Text 4"/>
+          <p:cNvSpPr/>
+          <p:nvPr/>
+        </p:nvSpPr>
+        <p:spPr>
+          <a:xfrm>
+            <a:off x="914400" y="2514600"/>
+            <a:ext cx="4754880" cy="822960"/>
+          </a:xfrm>
+          <a:prstGeom prst="rect">
+            <a:avLst/>
+          </a:prstGeom>
+          <a:noFill/>
+          <a:ln/>
+        </p:spPr>
+        <p:txBody>
+          <a:bodyPr wrap="square" rtlCol="0" anchor="ctr"/>
+          <a:lstStyle/>
+          <a:p>
+            <a:pPr indent="0" marL="0">
+              <a:buNone/>
+            </a:pPr>
+            <a:r>
+              <a:rPr lang="en-US" sz="1600" dirty="0">
                 <a:solidFill>
                   <a:srgbClr val="1A1A1A"/>
                 </a:solidFill>
@@ -3706,16 +3970,99 @@
                 <a:ea typeface="Calibri" pitchFamily="34" charset="-122"/>
                 <a:cs typeface="Calibri" pitchFamily="34" charset="-120"/>
               </a:rPr>
-              <a:t>Open source (licencia MIT)</a:t>
-            </a:r>
+              <a:t>Hacen trámites sin depender de nadie.</a:t>
+            </a:r>
+            <a:endParaRPr lang="en-US" sz="1600" dirty="0"/>
+          </a:p>
+        </p:txBody>
+      </p:sp>
+      <p:sp>
+        <p:nvSpPr>
+          <p:cNvPr id="7" name="Shape 5"/>
+          <p:cNvSpPr/>
+          <p:nvPr/>
+        </p:nvSpPr>
+        <p:spPr>
+          <a:xfrm>
+            <a:off x="6217920" y="1645920"/>
+            <a:ext cx="5303520" cy="1828800"/>
+          </a:xfrm>
+          <a:prstGeom prst="roundRect">
+            <a:avLst>
+              <a:gd name="adj" fmla="val 6000"/>
+            </a:avLst>
+          </a:prstGeom>
+          <a:solidFill>
+            <a:srgbClr val="F2F5FB"/>
+          </a:solidFill>
+          <a:ln/>
+        </p:spPr>
+      </p:sp>
+      <p:sp>
+        <p:nvSpPr>
+          <p:cNvPr id="8" name="Text 6"/>
+          <p:cNvSpPr/>
+          <p:nvPr/>
+        </p:nvSpPr>
+        <p:spPr>
+          <a:xfrm>
+            <a:off x="6492240" y="1874520"/>
+            <a:ext cx="4754880" cy="548640"/>
+          </a:xfrm>
+          <a:prstGeom prst="rect">
+            <a:avLst/>
+          </a:prstGeom>
+          <a:noFill/>
+          <a:ln/>
+        </p:spPr>
+        <p:txBody>
+          <a:bodyPr wrap="square" rtlCol="0" anchor="ctr"/>
+          <a:lstStyle/>
+          <a:p>
             <a:pPr indent="0" marL="0">
-              <a:lnSpc>
-                <a:spcPct val="110000"/>
-              </a:lnSpc>
-              <a:buNone/>
-            </a:pPr>
-            <a:r>
-              <a:rPr lang="en-US" sz="2000" dirty="0">
+              <a:buNone/>
+            </a:pPr>
+            <a:r>
+              <a:rPr lang="en-US" sz="2200" b="1" dirty="0">
+                <a:solidFill>
+                  <a:srgbClr val="0B3D91"/>
+                </a:solidFill>
+                <a:latin typeface="Georgia" pitchFamily="34" charset="0"/>
+                <a:ea typeface="Georgia" pitchFamily="34" charset="-122"/>
+                <a:cs typeface="Georgia" pitchFamily="34" charset="-120"/>
+              </a:rPr>
+              <a:t>Privacidad</a:t>
+            </a:r>
+            <a:endParaRPr lang="en-US" sz="2200" dirty="0"/>
+          </a:p>
+        </p:txBody>
+      </p:sp>
+      <p:sp>
+        <p:nvSpPr>
+          <p:cNvPr id="9" name="Text 7"/>
+          <p:cNvSpPr/>
+          <p:nvPr/>
+        </p:nvSpPr>
+        <p:spPr>
+          <a:xfrm>
+            <a:off x="6492240" y="2514600"/>
+            <a:ext cx="4754880" cy="822960"/>
+          </a:xfrm>
+          <a:prstGeom prst="rect">
+            <a:avLst/>
+          </a:prstGeom>
+          <a:noFill/>
+          <a:ln/>
+        </p:spPr>
+        <p:txBody>
+          <a:bodyPr wrap="square" rtlCol="0" anchor="ctr"/>
+          <a:lstStyle/>
+          <a:p>
+            <a:pPr indent="0" marL="0">
+              <a:buNone/>
+            </a:pPr>
+            <a:r>
+              <a:rPr lang="en-US" sz="1600" dirty="0">
                 <a:solidFill>
                   <a:srgbClr val="1A1A1A"/>
                 </a:solidFill>
@@ -3723,17 +4070,99 @@
                 <a:ea typeface="Calibri" pitchFamily="34" charset="-122"/>
                 <a:cs typeface="Calibri" pitchFamily="34" charset="-120"/>
               </a:rPr>
-              <a:t> — el GORE puede adoptarlo y mejorarlo (DL 1412, art. 29).
-</a:t>
-            </a:r>
+              <a:t>Sus datos no salen del dispositivo.</a:t>
+            </a:r>
+            <a:endParaRPr lang="en-US" sz="1600" dirty="0"/>
+          </a:p>
+        </p:txBody>
+      </p:sp>
+      <p:sp>
+        <p:nvSpPr>
+          <p:cNvPr id="10" name="Shape 8"/>
+          <p:cNvSpPr/>
+          <p:nvPr/>
+        </p:nvSpPr>
+        <p:spPr>
+          <a:xfrm>
+            <a:off x="640080" y="3749040"/>
+            <a:ext cx="5303520" cy="1828800"/>
+          </a:xfrm>
+          <a:prstGeom prst="roundRect">
+            <a:avLst>
+              <a:gd name="adj" fmla="val 6000"/>
+            </a:avLst>
+          </a:prstGeom>
+          <a:solidFill>
+            <a:srgbClr val="F2F5FB"/>
+          </a:solidFill>
+          <a:ln/>
+        </p:spPr>
+      </p:sp>
+      <p:sp>
+        <p:nvSpPr>
+          <p:cNvPr id="11" name="Text 9"/>
+          <p:cNvSpPr/>
+          <p:nvPr/>
+        </p:nvSpPr>
+        <p:spPr>
+          <a:xfrm>
+            <a:off x="914400" y="3977640"/>
+            <a:ext cx="4754880" cy="548640"/>
+          </a:xfrm>
+          <a:prstGeom prst="rect">
+            <a:avLst/>
+          </a:prstGeom>
+          <a:noFill/>
+          <a:ln/>
+        </p:spPr>
+        <p:txBody>
+          <a:bodyPr wrap="square" rtlCol="0" anchor="ctr"/>
+          <a:lstStyle/>
+          <a:p>
             <a:pPr indent="0" marL="0">
-              <a:lnSpc>
-                <a:spcPct val="110000"/>
-              </a:lnSpc>
-              <a:buNone/>
-            </a:pPr>
-            <a:r>
-              <a:rPr lang="en-US" sz="2000" b="1" dirty="0">
+              <a:buNone/>
+            </a:pPr>
+            <a:r>
+              <a:rPr lang="en-US" sz="2200" b="1" dirty="0">
+                <a:solidFill>
+                  <a:srgbClr val="0B3D91"/>
+                </a:solidFill>
+                <a:latin typeface="Georgia" pitchFamily="34" charset="0"/>
+                <a:ea typeface="Georgia" pitchFamily="34" charset="-122"/>
+                <a:cs typeface="Georgia" pitchFamily="34" charset="-120"/>
+              </a:rPr>
+              <a:t>Inclusión</a:t>
+            </a:r>
+            <a:endParaRPr lang="en-US" sz="2200" dirty="0"/>
+          </a:p>
+        </p:txBody>
+      </p:sp>
+      <p:sp>
+        <p:nvSpPr>
+          <p:cNvPr id="12" name="Text 10"/>
+          <p:cNvSpPr/>
+          <p:nvPr/>
+        </p:nvSpPr>
+        <p:spPr>
+          <a:xfrm>
+            <a:off x="914400" y="4617720"/>
+            <a:ext cx="4754880" cy="822960"/>
+          </a:xfrm>
+          <a:prstGeom prst="rect">
+            <a:avLst/>
+          </a:prstGeom>
+          <a:noFill/>
+          <a:ln/>
+        </p:spPr>
+        <p:txBody>
+          <a:bodyPr wrap="square" rtlCol="0" anchor="ctr"/>
+          <a:lstStyle/>
+          <a:p>
+            <a:pPr indent="0" marL="0">
+              <a:buNone/>
+            </a:pPr>
+            <a:r>
+              <a:rPr lang="en-US" sz="1600" dirty="0">
                 <a:solidFill>
                   <a:srgbClr val="1A1A1A"/>
                 </a:solidFill>
@@ -3741,16 +4170,99 @@
                 <a:ea typeface="Calibri" pitchFamily="34" charset="-122"/>
                 <a:cs typeface="Calibri" pitchFamily="34" charset="-120"/>
               </a:rPr>
-              <a:t>Componentes accesibles reutilizables</a:t>
-            </a:r>
+              <a:t>Pensado también para hablantes de quechua.</a:t>
+            </a:r>
+            <a:endParaRPr lang="en-US" sz="1600" dirty="0"/>
+          </a:p>
+        </p:txBody>
+      </p:sp>
+      <p:sp>
+        <p:nvSpPr>
+          <p:cNvPr id="13" name="Shape 11"/>
+          <p:cNvSpPr/>
+          <p:nvPr/>
+        </p:nvSpPr>
+        <p:spPr>
+          <a:xfrm>
+            <a:off x="6217920" y="3749040"/>
+            <a:ext cx="5303520" cy="1828800"/>
+          </a:xfrm>
+          <a:prstGeom prst="roundRect">
+            <a:avLst>
+              <a:gd name="adj" fmla="val 6000"/>
+            </a:avLst>
+          </a:prstGeom>
+          <a:solidFill>
+            <a:srgbClr val="F2F5FB"/>
+          </a:solidFill>
+          <a:ln/>
+        </p:spPr>
+      </p:sp>
+      <p:sp>
+        <p:nvSpPr>
+          <p:cNvPr id="14" name="Text 12"/>
+          <p:cNvSpPr/>
+          <p:nvPr/>
+        </p:nvSpPr>
+        <p:spPr>
+          <a:xfrm>
+            <a:off x="6492240" y="3977640"/>
+            <a:ext cx="4754880" cy="548640"/>
+          </a:xfrm>
+          <a:prstGeom prst="rect">
+            <a:avLst/>
+          </a:prstGeom>
+          <a:noFill/>
+          <a:ln/>
+        </p:spPr>
+        <p:txBody>
+          <a:bodyPr wrap="square" rtlCol="0" anchor="ctr"/>
+          <a:lstStyle/>
+          <a:p>
             <a:pPr indent="0" marL="0">
-              <a:lnSpc>
-                <a:spcPct val="110000"/>
-              </a:lnSpc>
-              <a:buNone/>
-            </a:pPr>
-            <a:r>
-              <a:rPr lang="en-US" sz="2000" dirty="0">
+              <a:buNone/>
+            </a:pPr>
+            <a:r>
+              <a:rPr lang="en-US" sz="2200" b="1" dirty="0">
+                <a:solidFill>
+                  <a:srgbClr val="0B3D91"/>
+                </a:solidFill>
+                <a:latin typeface="Georgia" pitchFamily="34" charset="0"/>
+                <a:ea typeface="Georgia" pitchFamily="34" charset="-122"/>
+                <a:cs typeface="Georgia" pitchFamily="34" charset="-120"/>
+              </a:rPr>
+              <a:t>Transparencia</a:t>
+            </a:r>
+            <a:endParaRPr lang="en-US" sz="2200" dirty="0"/>
+          </a:p>
+        </p:txBody>
+      </p:sp>
+      <p:sp>
+        <p:nvSpPr>
+          <p:cNvPr id="15" name="Text 13"/>
+          <p:cNvSpPr/>
+          <p:nvPr/>
+        </p:nvSpPr>
+        <p:spPr>
+          <a:xfrm>
+            <a:off x="6492240" y="4617720"/>
+            <a:ext cx="4754880" cy="822960"/>
+          </a:xfrm>
+          <a:prstGeom prst="rect">
+            <a:avLst/>
+          </a:prstGeom>
+          <a:noFill/>
+          <a:ln/>
+        </p:spPr>
+        <p:txBody>
+          <a:bodyPr wrap="square" rtlCol="0" anchor="ctr"/>
+          <a:lstStyle/>
+          <a:p>
+            <a:pPr indent="0" marL="0">
+              <a:buNone/>
+            </a:pPr>
+            <a:r>
+              <a:rPr lang="en-US" sz="1600" dirty="0">
                 <a:solidFill>
                   <a:srgbClr val="1A1A1A"/>
                 </a:solidFill>
@@ -3758,79 +4270,9 @@
                 <a:ea typeface="Calibri" pitchFamily="34" charset="-122"/>
                 <a:cs typeface="Calibri" pitchFamily="34" charset="-120"/>
               </a:rPr>
-              <a:t> — se integran por partes a los sistemas actuales.
-</a:t>
-            </a:r>
-            <a:pPr indent="0" marL="0">
-              <a:lnSpc>
-                <a:spcPct val="110000"/>
-              </a:lnSpc>
-              <a:buNone/>
-            </a:pPr>
-            <a:r>
-              <a:rPr lang="en-US" sz="2000" b="1" dirty="0">
-                <a:solidFill>
-                  <a:srgbClr val="1A1A1A"/>
-                </a:solidFill>
-                <a:latin typeface="Calibri" pitchFamily="34" charset="0"/>
-                <a:ea typeface="Calibri" pitchFamily="34" charset="-122"/>
-                <a:cs typeface="Calibri" pitchFamily="34" charset="-120"/>
-              </a:rPr>
-              <a:t>Datos 100% sintéticos, offline, sin IA en la nube</a:t>
-            </a:r>
-            <a:pPr indent="0" marL="0">
-              <a:lnSpc>
-                <a:spcPct val="110000"/>
-              </a:lnSpc>
-              <a:buNone/>
-            </a:pPr>
-            <a:r>
-              <a:rPr lang="en-US" sz="2000" dirty="0">
-                <a:solidFill>
-                  <a:srgbClr val="1A1A1A"/>
-                </a:solidFill>
-                <a:latin typeface="Calibri" pitchFamily="34" charset="0"/>
-                <a:ea typeface="Calibri" pitchFamily="34" charset="-122"/>
-                <a:cs typeface="Calibri" pitchFamily="34" charset="-120"/>
-              </a:rPr>
-              <a:t> — sin tocar sistemas reales ni exponer credenciales.
-</a:t>
-            </a:r>
-            <a:pPr indent="0" marL="0">
-              <a:lnSpc>
-                <a:spcPct val="110000"/>
-              </a:lnSpc>
-              <a:buNone/>
-            </a:pPr>
-            <a:r>
-              <a:rPr lang="en-US" sz="2000" b="1" dirty="0">
-                <a:solidFill>
-                  <a:srgbClr val="1A1A1A"/>
-                </a:solidFill>
-                <a:latin typeface="Calibri" pitchFamily="34" charset="0"/>
-                <a:ea typeface="Calibri" pitchFamily="34" charset="-122"/>
-                <a:cs typeface="Calibri" pitchFamily="34" charset="-120"/>
-              </a:rPr>
-              <a:t>Estándares</a:t>
-            </a:r>
-            <a:pPr indent="0" marL="0">
-              <a:lnSpc>
-                <a:spcPct val="110000"/>
-              </a:lnSpc>
-              <a:buNone/>
-            </a:pPr>
-            <a:r>
-              <a:rPr lang="en-US" sz="2000" dirty="0">
-                <a:solidFill>
-                  <a:srgbClr val="1A1A1A"/>
-                </a:solidFill>
-                <a:latin typeface="Calibri" pitchFamily="34" charset="0"/>
-                <a:ea typeface="Calibri" pitchFamily="34" charset="-122"/>
-                <a:cs typeface="Calibri" pitchFamily="34" charset="-120"/>
-              </a:rPr>
-              <a:t> — WCAG 2.2, Ley 29973, Ley 29733 y Lineamientos de Accesibilidad del Estado.</a:t>
-            </a:r>
-            <a:endParaRPr lang="en-US" sz="2000" dirty="0"/>
+              <a:t>Garantiza el derecho a la información pública.</a:t>
+            </a:r>
+            <a:endParaRPr lang="en-US" sz="1600" dirty="0"/>
           </a:p>
         </p:txBody>
       </p:sp>
@@ -3874,8 +4316,8 @@
         </p:nvSpPr>
         <p:spPr>
           <a:xfrm>
-            <a:off x="640080" y="457200"/>
-            <a:ext cx="10908792" cy="822960"/>
+            <a:off x="640080" y="365760"/>
+            <a:ext cx="10908792" cy="731520"/>
           </a:xfrm>
           <a:prstGeom prst="rect">
             <a:avLst/>
@@ -3891,7 +4333,7 @@
               <a:buNone/>
             </a:pPr>
             <a:r>
-              <a:rPr lang="en-US" sz="3400" b="1" dirty="0">
+              <a:rPr lang="en-US" sz="3200" b="1" dirty="0">
                 <a:solidFill>
                   <a:srgbClr val="0B3D91"/>
                 </a:solidFill>
@@ -3899,15 +4341,526 @@
                 <a:ea typeface="Georgia" pitchFamily="34" charset="-122"/>
                 <a:cs typeface="Georgia" pitchFamily="34" charset="-120"/>
               </a:rPr>
+              <a:t>Apertura, reutilización y ética</a:t>
+            </a:r>
+            <a:endParaRPr lang="en-US" sz="3200" dirty="0"/>
+          </a:p>
+        </p:txBody>
+      </p:sp>
+      <p:sp>
+        <p:nvSpPr>
+          <p:cNvPr id="3" name="Shape 1"/>
+          <p:cNvSpPr/>
+          <p:nvPr/>
+        </p:nvSpPr>
+        <p:spPr>
+          <a:xfrm>
+            <a:off x="640080" y="1051560"/>
+            <a:ext cx="1097280" cy="45720"/>
+          </a:xfrm>
+          <a:prstGeom prst="rect">
+            <a:avLst/>
+          </a:prstGeom>
+          <a:solidFill>
+            <a:srgbClr val="E0A100"/>
+          </a:solidFill>
+          <a:ln/>
+        </p:spPr>
+      </p:sp>
+      <p:sp>
+        <p:nvSpPr>
+          <p:cNvPr id="4" name="Shape 2"/>
+          <p:cNvSpPr/>
+          <p:nvPr/>
+        </p:nvSpPr>
+        <p:spPr>
+          <a:xfrm>
+            <a:off x="640080" y="1645920"/>
+            <a:ext cx="5303520" cy="1828800"/>
+          </a:xfrm>
+          <a:prstGeom prst="roundRect">
+            <a:avLst>
+              <a:gd name="adj" fmla="val 6000"/>
+            </a:avLst>
+          </a:prstGeom>
+          <a:solidFill>
+            <a:srgbClr val="F2F5FB"/>
+          </a:solidFill>
+          <a:ln/>
+        </p:spPr>
+      </p:sp>
+      <p:sp>
+        <p:nvSpPr>
+          <p:cNvPr id="5" name="Text 3"/>
+          <p:cNvSpPr/>
+          <p:nvPr/>
+        </p:nvSpPr>
+        <p:spPr>
+          <a:xfrm>
+            <a:off x="914400" y="1874520"/>
+            <a:ext cx="4754880" cy="548640"/>
+          </a:xfrm>
+          <a:prstGeom prst="rect">
+            <a:avLst/>
+          </a:prstGeom>
+          <a:noFill/>
+          <a:ln/>
+        </p:spPr>
+        <p:txBody>
+          <a:bodyPr wrap="square" rtlCol="0" anchor="ctr"/>
+          <a:lstStyle/>
+          <a:p>
+            <a:pPr indent="0" marL="0">
+              <a:buNone/>
+            </a:pPr>
+            <a:r>
+              <a:rPr lang="en-US" sz="2000" b="1" dirty="0">
+                <a:solidFill>
+                  <a:srgbClr val="0B3D91"/>
+                </a:solidFill>
+                <a:latin typeface="Georgia" pitchFamily="34" charset="0"/>
+                <a:ea typeface="Georgia" pitchFamily="34" charset="-122"/>
+                <a:cs typeface="Georgia" pitchFamily="34" charset="-120"/>
+              </a:rPr>
+              <a:t>Licencia Libre (MIT)</a:t>
+            </a:r>
+            <a:endParaRPr lang="en-US" sz="2000" dirty="0"/>
+          </a:p>
+        </p:txBody>
+      </p:sp>
+      <p:sp>
+        <p:nvSpPr>
+          <p:cNvPr id="6" name="Text 4"/>
+          <p:cNvSpPr/>
+          <p:nvPr/>
+        </p:nvSpPr>
+        <p:spPr>
+          <a:xfrm>
+            <a:off x="914400" y="2514600"/>
+            <a:ext cx="4754880" cy="822960"/>
+          </a:xfrm>
+          <a:prstGeom prst="rect">
+            <a:avLst/>
+          </a:prstGeom>
+          <a:noFill/>
+          <a:ln/>
+        </p:spPr>
+        <p:txBody>
+          <a:bodyPr wrap="square" rtlCol="0" anchor="ctr"/>
+          <a:lstStyle/>
+          <a:p>
+            <a:pPr indent="0" marL="0">
+              <a:buNone/>
+            </a:pPr>
+            <a:r>
+              <a:rPr lang="en-US" sz="1450" dirty="0">
+                <a:solidFill>
+                  <a:srgbClr val="1A1A1A"/>
+                </a:solidFill>
+                <a:latin typeface="Calibri" pitchFamily="34" charset="0"/>
+                <a:ea typeface="Calibri" pitchFamily="34" charset="-122"/>
+                <a:cs typeface="Calibri" pitchFamily="34" charset="-120"/>
+              </a:rPr>
+              <a:t>Código 100% abierto que el GORE Cusco puede adoptar, mejorar y desplegar legalmente (D.L. 1412, art. 29).</a:t>
+            </a:r>
+            <a:endParaRPr lang="en-US" sz="1450" dirty="0"/>
+          </a:p>
+        </p:txBody>
+      </p:sp>
+      <p:sp>
+        <p:nvSpPr>
+          <p:cNvPr id="7" name="Shape 5"/>
+          <p:cNvSpPr/>
+          <p:nvPr/>
+        </p:nvSpPr>
+        <p:spPr>
+          <a:xfrm>
+            <a:off x="6217920" y="1645920"/>
+            <a:ext cx="5303520" cy="1828800"/>
+          </a:xfrm>
+          <a:prstGeom prst="roundRect">
+            <a:avLst>
+              <a:gd name="adj" fmla="val 6000"/>
+            </a:avLst>
+          </a:prstGeom>
+          <a:solidFill>
+            <a:srgbClr val="F2F5FB"/>
+          </a:solidFill>
+          <a:ln/>
+        </p:spPr>
+      </p:sp>
+      <p:sp>
+        <p:nvSpPr>
+          <p:cNvPr id="8" name="Text 6"/>
+          <p:cNvSpPr/>
+          <p:nvPr/>
+        </p:nvSpPr>
+        <p:spPr>
+          <a:xfrm>
+            <a:off x="6492240" y="1874520"/>
+            <a:ext cx="4754880" cy="548640"/>
+          </a:xfrm>
+          <a:prstGeom prst="rect">
+            <a:avLst/>
+          </a:prstGeom>
+          <a:noFill/>
+          <a:ln/>
+        </p:spPr>
+        <p:txBody>
+          <a:bodyPr wrap="square" rtlCol="0" anchor="ctr"/>
+          <a:lstStyle/>
+          <a:p>
+            <a:pPr indent="0" marL="0">
+              <a:buNone/>
+            </a:pPr>
+            <a:r>
+              <a:rPr lang="en-US" sz="2000" b="1" dirty="0">
+                <a:solidFill>
+                  <a:srgbClr val="0B3D91"/>
+                </a:solidFill>
+                <a:latin typeface="Georgia" pitchFamily="34" charset="0"/>
+                <a:ea typeface="Georgia" pitchFamily="34" charset="-122"/>
+                <a:cs typeface="Georgia" pitchFamily="34" charset="-120"/>
+              </a:rPr>
+              <a:t>Diseño Reutilizable</a:t>
+            </a:r>
+            <a:endParaRPr lang="en-US" sz="2000" dirty="0"/>
+          </a:p>
+        </p:txBody>
+      </p:sp>
+      <p:sp>
+        <p:nvSpPr>
+          <p:cNvPr id="9" name="Text 7"/>
+          <p:cNvSpPr/>
+          <p:nvPr/>
+        </p:nvSpPr>
+        <p:spPr>
+          <a:xfrm>
+            <a:off x="6492240" y="2514600"/>
+            <a:ext cx="4754880" cy="822960"/>
+          </a:xfrm>
+          <a:prstGeom prst="rect">
+            <a:avLst/>
+          </a:prstGeom>
+          <a:noFill/>
+          <a:ln/>
+        </p:spPr>
+        <p:txBody>
+          <a:bodyPr wrap="square" rtlCol="0" anchor="ctr"/>
+          <a:lstStyle/>
+          <a:p>
+            <a:pPr indent="0" marL="0">
+              <a:buNone/>
+            </a:pPr>
+            <a:r>
+              <a:rPr lang="en-US" sz="1450" dirty="0">
+                <a:solidFill>
+                  <a:srgbClr val="1A1A1A"/>
+                </a:solidFill>
+                <a:latin typeface="Calibri" pitchFamily="34" charset="0"/>
+                <a:ea typeface="Calibri" pitchFamily="34" charset="-122"/>
+                <a:cs typeface="Calibri" pitchFamily="34" charset="-120"/>
+              </a:rPr>
+              <a:t>Componentes modulares de accesibilidad (stepper, forms) listos para integrarse a los sistemas actuales del GRC.</a:t>
+            </a:r>
+            <a:endParaRPr lang="en-US" sz="1450" dirty="0"/>
+          </a:p>
+        </p:txBody>
+      </p:sp>
+      <p:sp>
+        <p:nvSpPr>
+          <p:cNvPr id="10" name="Shape 8"/>
+          <p:cNvSpPr/>
+          <p:nvPr/>
+        </p:nvSpPr>
+        <p:spPr>
+          <a:xfrm>
+            <a:off x="640080" y="3749040"/>
+            <a:ext cx="5303520" cy="1828800"/>
+          </a:xfrm>
+          <a:prstGeom prst="roundRect">
+            <a:avLst>
+              <a:gd name="adj" fmla="val 6000"/>
+            </a:avLst>
+          </a:prstGeom>
+          <a:solidFill>
+            <a:srgbClr val="F2F5FB"/>
+          </a:solidFill>
+          <a:ln/>
+        </p:spPr>
+      </p:sp>
+      <p:sp>
+        <p:nvSpPr>
+          <p:cNvPr id="11" name="Text 9"/>
+          <p:cNvSpPr/>
+          <p:nvPr/>
+        </p:nvSpPr>
+        <p:spPr>
+          <a:xfrm>
+            <a:off x="914400" y="3977640"/>
+            <a:ext cx="4754880" cy="548640"/>
+          </a:xfrm>
+          <a:prstGeom prst="rect">
+            <a:avLst/>
+          </a:prstGeom>
+          <a:noFill/>
+          <a:ln/>
+        </p:spPr>
+        <p:txBody>
+          <a:bodyPr wrap="square" rtlCol="0" anchor="ctr"/>
+          <a:lstStyle/>
+          <a:p>
+            <a:pPr indent="0" marL="0">
+              <a:buNone/>
+            </a:pPr>
+            <a:r>
+              <a:rPr lang="en-US" sz="2000" b="1" dirty="0">
+                <a:solidFill>
+                  <a:srgbClr val="0B3D91"/>
+                </a:solidFill>
+                <a:latin typeface="Georgia" pitchFamily="34" charset="0"/>
+                <a:ea typeface="Georgia" pitchFamily="34" charset="-122"/>
+                <a:cs typeface="Georgia" pitchFamily="34" charset="-120"/>
+              </a:rPr>
+              <a:t>Privacidad por Diseño</a:t>
+            </a:r>
+            <a:endParaRPr lang="en-US" sz="2000" dirty="0"/>
+          </a:p>
+        </p:txBody>
+      </p:sp>
+      <p:sp>
+        <p:nvSpPr>
+          <p:cNvPr id="12" name="Text 10"/>
+          <p:cNvSpPr/>
+          <p:nvPr/>
+        </p:nvSpPr>
+        <p:spPr>
+          <a:xfrm>
+            <a:off x="914400" y="4617720"/>
+            <a:ext cx="4754880" cy="822960"/>
+          </a:xfrm>
+          <a:prstGeom prst="rect">
+            <a:avLst/>
+          </a:prstGeom>
+          <a:noFill/>
+          <a:ln/>
+        </p:spPr>
+        <p:txBody>
+          <a:bodyPr wrap="square" rtlCol="0" anchor="ctr"/>
+          <a:lstStyle/>
+          <a:p>
+            <a:pPr indent="0" marL="0">
+              <a:buNone/>
+            </a:pPr>
+            <a:r>
+              <a:rPr lang="en-US" sz="1450" dirty="0">
+                <a:solidFill>
+                  <a:srgbClr val="1A1A1A"/>
+                </a:solidFill>
+                <a:latin typeface="Calibri" pitchFamily="34" charset="0"/>
+                <a:ea typeface="Calibri" pitchFamily="34" charset="-122"/>
+                <a:cs typeface="Calibri" pitchFamily="34" charset="-120"/>
+              </a:rPr>
+              <a:t>Datos 100% sintéticos. Sin IA en la nube, sin datos personales y operable de forma local (offline).</a:t>
+            </a:r>
+            <a:endParaRPr lang="en-US" sz="1450" dirty="0"/>
+          </a:p>
+        </p:txBody>
+      </p:sp>
+      <p:sp>
+        <p:nvSpPr>
+          <p:cNvPr id="13" name="Shape 11"/>
+          <p:cNvSpPr/>
+          <p:nvPr/>
+        </p:nvSpPr>
+        <p:spPr>
+          <a:xfrm>
+            <a:off x="6217920" y="3749040"/>
+            <a:ext cx="5303520" cy="1828800"/>
+          </a:xfrm>
+          <a:prstGeom prst="roundRect">
+            <a:avLst>
+              <a:gd name="adj" fmla="val 6000"/>
+            </a:avLst>
+          </a:prstGeom>
+          <a:solidFill>
+            <a:srgbClr val="F2F5FB"/>
+          </a:solidFill>
+          <a:ln/>
+        </p:spPr>
+      </p:sp>
+      <p:sp>
+        <p:nvSpPr>
+          <p:cNvPr id="14" name="Text 12"/>
+          <p:cNvSpPr/>
+          <p:nvPr/>
+        </p:nvSpPr>
+        <p:spPr>
+          <a:xfrm>
+            <a:off x="6492240" y="3977640"/>
+            <a:ext cx="4754880" cy="548640"/>
+          </a:xfrm>
+          <a:prstGeom prst="rect">
+            <a:avLst/>
+          </a:prstGeom>
+          <a:noFill/>
+          <a:ln/>
+        </p:spPr>
+        <p:txBody>
+          <a:bodyPr wrap="square" rtlCol="0" anchor="ctr"/>
+          <a:lstStyle/>
+          <a:p>
+            <a:pPr indent="0" marL="0">
+              <a:buNone/>
+            </a:pPr>
+            <a:r>
+              <a:rPr lang="en-US" sz="2000" b="1" dirty="0">
+                <a:solidFill>
+                  <a:srgbClr val="0B3D91"/>
+                </a:solidFill>
+                <a:latin typeface="Georgia" pitchFamily="34" charset="0"/>
+                <a:ea typeface="Georgia" pitchFamily="34" charset="-122"/>
+                <a:cs typeface="Georgia" pitchFamily="34" charset="-120"/>
+              </a:rPr>
+              <a:t>Cumplimiento de Estándares</a:t>
+            </a:r>
+            <a:endParaRPr lang="en-US" sz="2000" dirty="0"/>
+          </a:p>
+        </p:txBody>
+      </p:sp>
+      <p:sp>
+        <p:nvSpPr>
+          <p:cNvPr id="15" name="Text 13"/>
+          <p:cNvSpPr/>
+          <p:nvPr/>
+        </p:nvSpPr>
+        <p:spPr>
+          <a:xfrm>
+            <a:off x="6492240" y="4617720"/>
+            <a:ext cx="4754880" cy="822960"/>
+          </a:xfrm>
+          <a:prstGeom prst="rect">
+            <a:avLst/>
+          </a:prstGeom>
+          <a:noFill/>
+          <a:ln/>
+        </p:spPr>
+        <p:txBody>
+          <a:bodyPr wrap="square" rtlCol="0" anchor="ctr"/>
+          <a:lstStyle/>
+          <a:p>
+            <a:pPr indent="0" marL="0">
+              <a:buNone/>
+            </a:pPr>
+            <a:r>
+              <a:rPr lang="en-US" sz="1450" dirty="0">
+                <a:solidFill>
+                  <a:srgbClr val="1A1A1A"/>
+                </a:solidFill>
+                <a:latin typeface="Calibri" pitchFamily="34" charset="0"/>
+                <a:ea typeface="Calibri" pitchFamily="34" charset="-122"/>
+                <a:cs typeface="Calibri" pitchFamily="34" charset="-120"/>
+              </a:rPr>
+              <a:t>Alineado a las pautas WCAG 2.2, Ley N° 29973 (Discapacidad) y Ley N° 29733 (Datos Personales).</a:t>
+            </a:r>
+            <a:endParaRPr lang="en-US" sz="1450" dirty="0"/>
+          </a:p>
+        </p:txBody>
+      </p:sp>
+    </p:spTree>
+  </p:cSld>
+  <p:clrMapOvr>
+    <a:masterClrMapping/>
+  </p:clrMapOvr>
+</p:sld>
+</file>
+
+<file path=ppt/slides/slide8.xml><?xml version="1.0" encoding="utf-8"?>
+<p:sld xmlns:a="http://schemas.openxmlformats.org/drawingml/2006/main" xmlns:r="http://schemas.openxmlformats.org/officeDocument/2006/relationships" xmlns:p="http://schemas.openxmlformats.org/presentationml/2006/main">
+  <p:cSld name="Slide 8">
+    <p:bg>
+      <p:bgPr>
+        <a:solidFill>
+          <a:srgbClr val="FFFFFF"/>
+        </a:solidFill>
+      </p:bgPr>
+    </p:bg>
+    <p:spTree>
+      <p:nvGrpSpPr>
+        <p:cNvPr id="1" name=""/>
+        <p:cNvGrpSpPr/>
+        <p:nvPr/>
+      </p:nvGrpSpPr>
+      <p:grpSpPr>
+        <a:xfrm>
+          <a:off x="0" y="0"/>
+          <a:ext cx="0" cy="0"/>
+          <a:chOff x="0" y="0"/>
+          <a:chExt cx="0" cy="0"/>
+        </a:xfrm>
+      </p:grpSpPr>
+      <p:sp>
+        <p:nvSpPr>
+          <p:cNvPr id="2" name="Text 0"/>
+          <p:cNvSpPr/>
+          <p:nvPr/>
+        </p:nvSpPr>
+        <p:spPr>
+          <a:xfrm>
+            <a:off x="640080" y="365760"/>
+            <a:ext cx="10908792" cy="731520"/>
+          </a:xfrm>
+          <a:prstGeom prst="rect">
+            <a:avLst/>
+          </a:prstGeom>
+          <a:noFill/>
+          <a:ln/>
+        </p:spPr>
+        <p:txBody>
+          <a:bodyPr wrap="square" rtlCol="0" anchor="ctr"/>
+          <a:lstStyle/>
+          <a:p>
+            <a:pPr algn="l" indent="0" marL="0">
+              <a:buNone/>
+            </a:pPr>
+            <a:r>
+              <a:rPr lang="en-US" sz="3200" b="1" dirty="0">
+                <a:solidFill>
+                  <a:srgbClr val="0B3D91"/>
+                </a:solidFill>
+                <a:latin typeface="Georgia" pitchFamily="34" charset="0"/>
+                <a:ea typeface="Georgia" pitchFamily="34" charset="-122"/>
+                <a:cs typeface="Georgia" pitchFamily="34" charset="-120"/>
+              </a:rPr>
               <a:t>Riesgos y mitigación</a:t>
             </a:r>
-            <a:endParaRPr lang="en-US" sz="3400" dirty="0"/>
-          </a:p>
-        </p:txBody>
+            <a:endParaRPr lang="en-US" sz="3200" dirty="0"/>
+          </a:p>
+        </p:txBody>
+      </p:sp>
+      <p:sp>
+        <p:nvSpPr>
+          <p:cNvPr id="3" name="Shape 1"/>
+          <p:cNvSpPr/>
+          <p:nvPr/>
+        </p:nvSpPr>
+        <p:spPr>
+          <a:xfrm>
+            <a:off x="640080" y="1051560"/>
+            <a:ext cx="1097280" cy="45720"/>
+          </a:xfrm>
+          <a:prstGeom prst="rect">
+            <a:avLst/>
+          </a:prstGeom>
+          <a:solidFill>
+            <a:srgbClr val="E0A100"/>
+          </a:solidFill>
+          <a:ln/>
+        </p:spPr>
       </p:sp>
       <p:graphicFrame>
         <p:nvGraphicFramePr>
-          <p:cNvPr id="8" name="Table 0"/>
+          <p:cNvPr id="9" name="Table 0"/>
           <p:cNvGraphicFramePr>
             <a:graphicFrameLocks noGrp="1"/>
           </p:cNvGraphicFramePr>
@@ -4633,9 +5586,9 @@
 </p:sld>
 </file>
 
-<file path=ppt/slides/slide8.xml><?xml version="1.0" encoding="utf-8"?>
+<file path=ppt/slides/slide9.xml><?xml version="1.0" encoding="utf-8"?>
 <p:sld xmlns:a="http://schemas.openxmlformats.org/drawingml/2006/main" xmlns:r="http://schemas.openxmlformats.org/officeDocument/2006/relationships" xmlns:p="http://schemas.openxmlformats.org/presentationml/2006/main">
-  <p:cSld name="Slide 8">
+  <p:cSld name="Slide 9">
     <p:bg>
       <p:bgPr>
         <a:solidFill>
@@ -4665,8 +5618,8 @@
         </p:nvSpPr>
         <p:spPr>
           <a:xfrm>
-            <a:off x="640080" y="457200"/>
-            <a:ext cx="10908792" cy="822960"/>
+            <a:off x="640080" y="365760"/>
+            <a:ext cx="10908792" cy="731520"/>
           </a:xfrm>
           <a:prstGeom prst="rect">
             <a:avLst/>
@@ -4682,7 +5635,7 @@
               <a:buNone/>
             </a:pPr>
             <a:r>
-              <a:rPr lang="en-US" sz="3400" b="1" dirty="0">
+              <a:rPr lang="en-US" sz="3200" b="1" dirty="0">
                 <a:solidFill>
                   <a:srgbClr val="0B3D91"/>
                 </a:solidFill>
@@ -4692,13 +5645,33 @@
               </a:rPr>
               <a:t>Próximos pasos</a:t>
             </a:r>
-            <a:endParaRPr lang="en-US" sz="3400" dirty="0"/>
-          </a:p>
-        </p:txBody>
-      </p:sp>
-      <p:sp>
-        <p:nvSpPr>
-          <p:cNvPr id="3" name="Text 1"/>
+            <a:endParaRPr lang="en-US" sz="3200" dirty="0"/>
+          </a:p>
+        </p:txBody>
+      </p:sp>
+      <p:sp>
+        <p:nvSpPr>
+          <p:cNvPr id="3" name="Shape 1"/>
+          <p:cNvSpPr/>
+          <p:nvPr/>
+        </p:nvSpPr>
+        <p:spPr>
+          <a:xfrm>
+            <a:off x="640080" y="1051560"/>
+            <a:ext cx="1097280" cy="45720"/>
+          </a:xfrm>
+          <a:prstGeom prst="rect">
+            <a:avLst/>
+          </a:prstGeom>
+          <a:solidFill>
+            <a:srgbClr val="E0A100"/>
+          </a:solidFill>
+          <a:ln/>
+        </p:spPr>
+      </p:sp>
+      <p:sp>
+        <p:nvSpPr>
+          <p:cNvPr id="4" name="Text 2"/>
           <p:cNvSpPr/>
           <p:nvPr/>
         </p:nvSpPr>
@@ -4790,116 +5763,6 @@
               <a:t>Integración real con el sistema Qellqa y autenticación con DNI accesible.</a:t>
             </a:r>
             <a:endParaRPr lang="en-US" sz="2100" dirty="0"/>
-          </a:p>
-        </p:txBody>
-      </p:sp>
-    </p:spTree>
-  </p:cSld>
-  <p:clrMapOvr>
-    <a:masterClrMapping/>
-  </p:clrMapOvr>
-</p:sld>
-</file>
-
-<file path=ppt/slides/slide9.xml><?xml version="1.0" encoding="utf-8"?>
-<p:sld xmlns:a="http://schemas.openxmlformats.org/drawingml/2006/main" xmlns:r="http://schemas.openxmlformats.org/officeDocument/2006/relationships" xmlns:p="http://schemas.openxmlformats.org/presentationml/2006/main">
-  <p:cSld name="Slide 9">
-    <p:bg>
-      <p:bgPr>
-        <a:solidFill>
-          <a:srgbClr val="0B3D91"/>
-        </a:solidFill>
-      </p:bgPr>
-    </p:bg>
-    <p:spTree>
-      <p:nvGrpSpPr>
-        <p:cNvPr id="1" name=""/>
-        <p:cNvGrpSpPr/>
-        <p:nvPr/>
-      </p:nvGrpSpPr>
-      <p:grpSpPr>
-        <a:xfrm>
-          <a:off x="0" y="0"/>
-          <a:ext cx="0" cy="0"/>
-          <a:chOff x="0" y="0"/>
-          <a:chExt cx="0" cy="0"/>
-        </a:xfrm>
-      </p:grpSpPr>
-      <p:sp>
-        <p:nvSpPr>
-          <p:cNvPr id="2" name="Text 0"/>
-          <p:cNvSpPr/>
-          <p:nvPr/>
-        </p:nvSpPr>
-        <p:spPr>
-          <a:xfrm>
-            <a:off x="914400" y="2103120"/>
-            <a:ext cx="10332720" cy="1645920"/>
-          </a:xfrm>
-          <a:prstGeom prst="rect">
-            <a:avLst/>
-          </a:prstGeom>
-          <a:noFill/>
-          <a:ln/>
-        </p:spPr>
-        <p:txBody>
-          <a:bodyPr wrap="square" rtlCol="0" anchor="ctr"/>
-          <a:lstStyle/>
-          <a:p>
-            <a:pPr indent="0" marL="0">
-              <a:buNone/>
-            </a:pPr>
-            <a:r>
-              <a:rPr lang="en-US" sz="3200" b="1" i="1" dirty="0">
-                <a:solidFill>
-                  <a:srgbClr val="FFFFFF"/>
-                </a:solidFill>
-                <a:latin typeface="Georgia" pitchFamily="34" charset="0"/>
-                <a:ea typeface="Georgia" pitchFamily="34" charset="-122"/>
-                <a:cs typeface="Georgia" pitchFamily="34" charset="-120"/>
-              </a:rPr>
-              <a:t>"Una ventanilla que funciona con las herramientas que la ciudadanía ya usa."</a:t>
-            </a:r>
-            <a:endParaRPr lang="en-US" sz="3200" dirty="0"/>
-          </a:p>
-        </p:txBody>
-      </p:sp>
-      <p:sp>
-        <p:nvSpPr>
-          <p:cNvPr id="3" name="Text 1"/>
-          <p:cNvSpPr/>
-          <p:nvPr/>
-        </p:nvSpPr>
-        <p:spPr>
-          <a:xfrm>
-            <a:off x="914400" y="5212080"/>
-            <a:ext cx="5486400" cy="640080"/>
-          </a:xfrm>
-          <a:prstGeom prst="rect">
-            <a:avLst/>
-          </a:prstGeom>
-          <a:noFill/>
-          <a:ln/>
-        </p:spPr>
-        <p:txBody>
-          <a:bodyPr wrap="square" rtlCol="0" anchor="ctr"/>
-          <a:lstStyle/>
-          <a:p>
-            <a:pPr indent="0" marL="0">
-              <a:buNone/>
-            </a:pPr>
-            <a:r>
-              <a:rPr lang="en-US" sz="2400" dirty="0">
-                <a:solidFill>
-                  <a:srgbClr val="E0A100"/>
-                </a:solidFill>
-                <a:latin typeface="Georgia" pitchFamily="34" charset="0"/>
-                <a:ea typeface="Georgia" pitchFamily="34" charset="-122"/>
-                <a:cs typeface="Georgia" pitchFamily="34" charset="-120"/>
-              </a:rPr>
-              <a:t>Gracias.</a:t>
-            </a:r>
-            <a:endParaRPr lang="en-US" sz="2400" dirty="0"/>
           </a:p>
         </p:txBody>
       </p:sp>

</xml_diff>